<commit_message>
Simplify interview deck around challenges, actions and practical contribution
</commit_message>
<xml_diff>
--- a/presentation/Nafis_Ismam_Docitalis_Interview.pptx
+++ b/presentation/Nafis_Ismam_Docitalis_Interview.pptx
@@ -506,7 +506,7 @@
           <a:lstStyle/>
           <a:p>
             <a:r>
-              <a:t>About 50 seconds. Docitalis publicly describes legal document translation for citizenship applications and an existing platform with human review. The internship brief extends into legal knowledge structuring and deterministic assembly. The brief supplies the Aprigliano connection; I am not asserting ownership or corporate affiliation. My aim is to understand the existing workflow before proposing changes. Source: https://docitalis.com/ and the supplied role description.</a:t>
+              <a:t>Opening, 35–45 seconds: “I understand this role as helping turn lawyer-approved expertise into repeatable software. I would first learn how your team works, rather than assume your process needs replacing.” Docitalis publicly describes document translation for Italian citizenship and human review. The role brief places this internship with Aprigliano legal teams and includes pleading assembly. I am distinguishing that brief from the public translation business. The legal team decides strategy; the software applies approved rules. Sources: https://docitalis.com/ and the supplied role description.</a:t>
             </a:r>
           </a:p>
         </p:txBody>
@@ -576,7 +576,7 @@
           <a:lstStyle/>
           <a:p>
             <a:r>
-              <a:t>About 60 seconds. The deterministic engine uses case facts and an approved strategy. A module declares its required facts, prerequisites, conflicts, order and source links. A version and fingerprint identify the rule snapshot. The separate source matrix stores provenance, jurisdiction, dates and relationships between authorities and modules. Retrieval supplies review evidence and warnings, not a legal strategy. A lawyer assesses applicability. Relational tables are a reasonable starting point; a graph is a later choice only if relationship queries justify it. Sources: role description; https://docitalis.com/privacy-cookie-policy/ for document confidentiality context.</a:t>
+              <a:t>About 50 seconds: “These are challenges I infer from the job description, not problems I have observed inside your company.” First, an experienced lawyer may know when an argument applies but the exceptions may not yet be written as software rules. Second, changing a rule can unintentionally change other documents. Third, a new authority may warrant review of existing arguments. Ask which of these consumes most team time. Do not say their current drafts contain errors or their system lacks tests. Avoid quantifying costs or promising a reduction without a baseline.</a:t>
             </a:r>
           </a:p>
         </p:txBody>
@@ -646,7 +646,7 @@
           <a:lstStyle/>
           <a:p>
             <a:r>
-              <a:t>About 60 seconds. I would join on-site discovery sessions, ask for a representative approved example and ask why each argument is included or excluded. I would record unknowns instead of guessing legal rules. Then I would translate one decision into explicit structured conditions, implement a narrow Python change and inspect the resulting trace with the domain expert. SQL can hold modules, conditions, prerequisites, citations and approvals. I would build proficiency in the team’s actual schema and formal methods. My current demos do not demonstrate SQL or Alloy implementation, so I would describe those as development areas rather than completed work.</a:t>
+              <a:t>About 60 seconds. “For unwritten knowledge, I would work through an approved example with a lawyer and record the conditions and exceptions. For consistency, I would compare changed software against examples with agreed expected results. For source review, I would keep links between authorities and the paragraphs that rely on them.” In engineering terms these are modular rules, regression tests, and a maintained legal sources matrix. Retrieval can assist source discovery, and AI can suggest concerns, but legal applicability and strategy remain with lawyers. A source change triggers investigation, not automatic replacement of every document. Human review remains essential.</a:t>
             </a:r>
           </a:p>
         </p:txBody>
@@ -716,7 +716,7 @@
           <a:lstStyle/>
           <a:p>
             <a:r>
-              <a:t>About 65 seconds. Regression tests compare a changed knowledge base with approved reference cases. A changed answer may be a defect or an intended legal update; the difference must be explained and reviewed. Passing every agreed test is a software acceptance criterion, not a guarantee of universal legal accuracy. My demonstration uses synthetic cases and simulated judgments, not real lawyer-approved histories. A new judgment is not necessarily a statutory amendment or applicable to every case. For appeals I would structure findings, reasoning and authorities and link them to issues; legal professionals would decide viable grounds. Protect confidential documents and use authorized or de-identified examples for testing.</a:t>
+              <a:t>About 60 seconds: “Suppose a new judgment is recorded. The first task is not to let AI rewrite the pleadings. It is to find the paragraphs linked to the relevant authority and ask a lawyer whether the judgment applies. If the lawyer approves a rule change, I would record a new version, rerun agreed examples and explain the differences.” It may be an interpretation rather than a statutory amendment. Regression means checking that a change did not break behavior we still expect. An intended legal update can legitimately change an expected result after review. Passing all agreed examples is not 100% legal accuracy. For the appeals extension, similar structured source links can help organise findings, reasoning and possible issues for lawyer assessment; they do not decide appeal grounds.</a:t>
             </a:r>
           </a:p>
         </p:txBody>
@@ -786,7 +786,7 @@
           <a:lstStyle/>
           <a:p>
             <a:r>
-              <a:t>About 65 seconds. My earlier research contribution was literature review, problem identification and initial design. I later moved to an LLM inference project while a sub-team continued the legal work. These repositories are recent demonstrations, separate from the published implementation. UkilRAG demonstrates versioned modules, deterministic assembly and four passing synthetic regression groups; it is not a complete generative RAG system. LearnRAG has seven passing component tests and separately captured real MiniLM/Qwen outputs. It omits requested inline citations, and three chunks with top-k three do not establish retrieval quality at scale. I can explain those limitations. My first-month proposal is to map one workflow, agree on an authorized reference set, implement one bounded rule set and measure the result with reviewers. The team’s priorities determine the actual schedule. I would ask which workflow is the best first target.</a:t>
+              <a:t>About 55 seconds. “My earlier research contribution was literature review, problem identification and initial design. I later moved to an LLM inference project while a sub-team continued the legal work. These recent demos are separate exercises.” UkilRAG demonstrates explicit document rules, a decision trace and regression checks on synthetic cases. LearnRAG has saved actual model outputs and separate component tests, with limitations recorded. Do not claim that either repository proves historical implementation ownership or production readiness. Proposed starting point: understand one workflow, agree on authorized examples and expected outputs, build one small pilot and measure reviewer effort and rework. Ask: “Which workflow would be the most useful starting point for this internship?”</a:t>
             </a:r>
           </a:p>
         </p:txBody>
@@ -3916,7 +3916,7 @@
               </a:defRPr>
             </a:pPr>
             <a:r>
-              <a:t>Making legal expertise repeatable and traceable</a:t>
+              <a:t>Make approved legal work easier to repeat</a:t>
             </a:r>
           </a:p>
         </p:txBody>
@@ -3955,7 +3955,7 @@
               </a:defRPr>
             </a:pPr>
             <a:r>
-              <a:t>My understanding of the Knowledge Systems &amp; AI Automation internship</a:t>
+              <a:t>My understanding of the role at Docitalis, working with Aprigliano’s legal teams.</a:t>
             </a:r>
           </a:p>
         </p:txBody>
@@ -4037,7 +4037,7 @@
               </a:defRPr>
             </a:pPr>
             <a:r>
-              <a:t>Sources: Docitalis website; supplied role description. Proposed approach, not an internal-system assessment.</a:t>
+              <a:t>Sources: Docitalis website and supplied role brief. This is a proposed approach, not an internal audit.</a:t>
             </a:r>
           </a:p>
         </p:txBody>
@@ -4089,8 +4089,8 @@
         </p:nvSpPr>
         <p:spPr>
           <a:xfrm>
-            <a:off x="594360" y="2697480"/>
-            <a:ext cx="3493008" cy="2560320"/>
+            <a:off x="594360" y="2779776"/>
+            <a:ext cx="3493008" cy="2084831"/>
           </a:xfrm>
           <a:prstGeom prst="roundRect">
             <a:avLst>
@@ -4134,8 +4134,8 @@
         </p:nvSpPr>
         <p:spPr>
           <a:xfrm>
-            <a:off x="804672" y="2916936"/>
-            <a:ext cx="3063240" cy="274320"/>
+            <a:off x="822960" y="3081528"/>
+            <a:ext cx="3035808" cy="640080"/>
           </a:xfrm>
           <a:prstGeom prst="rect">
             <a:avLst/>
@@ -4152,15 +4152,15 @@
               <a:spcAft>
                 <a:spcPts val="700"/>
               </a:spcAft>
-              <a:defRPr sz="1000" b="1">
-                <a:solidFill>
-                  <a:srgbClr val="147D78"/>
+              <a:defRPr sz="2100" b="1">
+                <a:solidFill>
+                  <a:srgbClr val="162B43"/>
                 </a:solidFill>
                 <a:latin typeface="DejaVu Sans"/>
               </a:defRPr>
             </a:pPr>
             <a:r>
-              <a:t>BUSINESS CONTEXT</a:t>
+              <a:t>Capture expertise</a:t>
             </a:r>
           </a:p>
         </p:txBody>
@@ -4173,8 +4173,8 @@
         </p:nvSpPr>
         <p:spPr>
           <a:xfrm>
-            <a:off x="804672" y="3337560"/>
-            <a:ext cx="3035808" cy="777240"/>
+            <a:off x="822960" y="4005072"/>
+            <a:ext cx="3035808" cy="667512"/>
           </a:xfrm>
           <a:prstGeom prst="rect">
             <a:avLst/>
@@ -4191,46 +4191,23 @@
               <a:spcAft>
                 <a:spcPts val="700"/>
               </a:spcAft>
-              <a:defRPr sz="1800" b="1">
-                <a:solidFill>
-                  <a:srgbClr val="162B43"/>
+              <a:defRPr sz="1700" b="0">
+                <a:solidFill>
+                  <a:srgbClr val="25364A"/>
                 </a:solidFill>
                 <a:latin typeface="DejaVu Sans"/>
               </a:defRPr>
             </a:pPr>
             <a:r>
-              <a:t>Documents people depend on</a:t>
-            </a:r>
-          </a:p>
-        </p:txBody>
-      </p:sp>
-      <p:sp>
-        <p:nvSpPr>
-          <p:cNvPr id="12" name="TextBox 11"/>
-          <p:cNvSpPr txBox="1"/>
-          <p:nvPr/>
-        </p:nvSpPr>
-        <p:spPr>
-          <a:xfrm>
-            <a:off x="804672" y="4224528"/>
-            <a:ext cx="3035808" cy="868680"/>
-          </a:xfrm>
-          <a:prstGeom prst="rect">
-            <a:avLst/>
-          </a:prstGeom>
-          <a:noFill/>
-        </p:spPr>
-        <p:txBody>
-          <a:bodyPr wrap="square" lIns="0" rIns="0" tIns="0" bIns="0">
-            <a:spAutoFit/>
-          </a:bodyPr>
-          <a:lstStyle/>
+              <a:t>Understand why lawyers</a:t>
+            </a:r>
+          </a:p>
           <a:p>
             <a:pPr>
               <a:spcAft>
                 <a:spcPts val="700"/>
               </a:spcAft>
-              <a:defRPr sz="1400" b="0">
+              <a:defRPr sz="1700" b="0">
                 <a:solidFill>
                   <a:srgbClr val="25364A"/>
                 </a:solidFill>
@@ -4238,21 +4215,21 @@
               </a:defRPr>
             </a:pPr>
             <a:r>
-              <a:t>Docitalis describes legal translations for Italian citizenship, with document preparation, review and certification.</a:t>
-            </a:r>
-          </a:p>
-        </p:txBody>
-      </p:sp>
-      <p:sp>
-        <p:nvSpPr>
-          <p:cNvPr id="13" name="Rounded Rectangle 12"/>
+              <a:t>choose each argument.</a:t>
+            </a:r>
+          </a:p>
+        </p:txBody>
+      </p:sp>
+      <p:sp>
+        <p:nvSpPr>
+          <p:cNvPr id="12" name="Rounded Rectangle 11"/>
           <p:cNvSpPr/>
           <p:nvPr/>
         </p:nvSpPr>
         <p:spPr>
           <a:xfrm>
-            <a:off x="4343400" y="2697480"/>
-            <a:ext cx="3493008" cy="2560320"/>
+            <a:off x="4343400" y="2779776"/>
+            <a:ext cx="3493008" cy="2084831"/>
           </a:xfrm>
           <a:prstGeom prst="roundRect">
             <a:avLst>
@@ -4290,14 +4267,14 @@
       </p:sp>
       <p:sp>
         <p:nvSpPr>
-          <p:cNvPr id="14" name="TextBox 13"/>
+          <p:cNvPr id="13" name="TextBox 12"/>
           <p:cNvSpPr txBox="1"/>
           <p:nvPr/>
         </p:nvSpPr>
         <p:spPr>
           <a:xfrm>
-            <a:off x="4553712" y="2916936"/>
-            <a:ext cx="3063240" cy="274320"/>
+            <a:off x="4572000" y="3081528"/>
+            <a:ext cx="3035808" cy="640080"/>
           </a:xfrm>
           <a:prstGeom prst="rect">
             <a:avLst/>
@@ -4314,29 +4291,29 @@
               <a:spcAft>
                 <a:spcPts val="700"/>
               </a:spcAft>
-              <a:defRPr sz="1000" b="1">
-                <a:solidFill>
-                  <a:srgbClr val="147D78"/>
+              <a:defRPr sz="2100" b="1">
+                <a:solidFill>
+                  <a:srgbClr val="162B43"/>
                 </a:solidFill>
                 <a:latin typeface="DejaVu Sans"/>
               </a:defRPr>
             </a:pPr>
             <a:r>
-              <a:t>ROLE CONTEXT</a:t>
-            </a:r>
-          </a:p>
-        </p:txBody>
-      </p:sp>
-      <p:sp>
-        <p:nvSpPr>
-          <p:cNvPr id="15" name="TextBox 14"/>
+              <a:t>Prepare consistent drafts</a:t>
+            </a:r>
+          </a:p>
+        </p:txBody>
+      </p:sp>
+      <p:sp>
+        <p:nvSpPr>
+          <p:cNvPr id="14" name="TextBox 13"/>
           <p:cNvSpPr txBox="1"/>
           <p:nvPr/>
         </p:nvSpPr>
         <p:spPr>
           <a:xfrm>
-            <a:off x="4553712" y="3337560"/>
-            <a:ext cx="3035808" cy="777240"/>
+            <a:off x="4572000" y="4005072"/>
+            <a:ext cx="3035808" cy="667512"/>
           </a:xfrm>
           <a:prstGeom prst="rect">
             <a:avLst/>
@@ -4353,46 +4330,23 @@
               <a:spcAft>
                 <a:spcPts val="700"/>
               </a:spcAft>
-              <a:defRPr sz="1800" b="1">
-                <a:solidFill>
-                  <a:srgbClr val="162B43"/>
+              <a:defRPr sz="1700" b="0">
+                <a:solidFill>
+                  <a:srgbClr val="25364A"/>
                 </a:solidFill>
                 <a:latin typeface="DejaVu Sans"/>
               </a:defRPr>
             </a:pPr>
             <a:r>
-              <a:t>Lawyer-approved knowledge</a:t>
-            </a:r>
-          </a:p>
-        </p:txBody>
-      </p:sp>
-      <p:sp>
-        <p:nvSpPr>
-          <p:cNvPr id="16" name="TextBox 15"/>
-          <p:cNvSpPr txBox="1"/>
-          <p:nvPr/>
-        </p:nvSpPr>
-        <p:spPr>
-          <a:xfrm>
-            <a:off x="4553712" y="4224528"/>
-            <a:ext cx="3035808" cy="868680"/>
-          </a:xfrm>
-          <a:prstGeom prst="rect">
-            <a:avLst/>
-          </a:prstGeom>
-          <a:noFill/>
-        </p:spPr>
-        <p:txBody>
-          <a:bodyPr wrap="square" lIns="0" rIns="0" tIns="0" bIns="0">
-            <a:spAutoFit/>
-          </a:bodyPr>
-          <a:lstStyle/>
+              <a:t>Apply agreed rules</a:t>
+            </a:r>
+          </a:p>
           <a:p>
             <a:pPr>
               <a:spcAft>
                 <a:spcPts val="700"/>
               </a:spcAft>
-              <a:defRPr sz="1400" b="0">
+              <a:defRPr sz="1700" b="0">
                 <a:solidFill>
                   <a:srgbClr val="25364A"/>
                 </a:solidFill>
@@ -4400,21 +4354,21 @@
               </a:defRPr>
             </a:pPr>
             <a:r>
-              <a:t>The brief places discovery with legal teams at Aprigliano: extract facts, arguments, conditions and exceptions.</a:t>
-            </a:r>
-          </a:p>
-        </p:txBody>
-      </p:sp>
-      <p:sp>
-        <p:nvSpPr>
-          <p:cNvPr id="17" name="Rounded Rectangle 16"/>
+              <a:t>to the facts of a case.</a:t>
+            </a:r>
+          </a:p>
+        </p:txBody>
+      </p:sp>
+      <p:sp>
+        <p:nvSpPr>
+          <p:cNvPr id="15" name="Rounded Rectangle 14"/>
           <p:cNvSpPr/>
           <p:nvPr/>
         </p:nvSpPr>
         <p:spPr>
           <a:xfrm>
-            <a:off x="8092440" y="2697480"/>
-            <a:ext cx="3493008" cy="2560320"/>
+            <a:off x="8092440" y="2779776"/>
+            <a:ext cx="3493008" cy="2084831"/>
           </a:xfrm>
           <a:prstGeom prst="roundRect">
             <a:avLst>
@@ -4452,14 +4406,14 @@
       </p:sp>
       <p:sp>
         <p:nvSpPr>
-          <p:cNvPr id="18" name="TextBox 17"/>
+          <p:cNvPr id="16" name="TextBox 15"/>
           <p:cNvSpPr txBox="1"/>
           <p:nvPr/>
         </p:nvSpPr>
         <p:spPr>
           <a:xfrm>
-            <a:off x="8302752" y="2916936"/>
-            <a:ext cx="3063240" cy="274320"/>
+            <a:off x="8321040" y="3081528"/>
+            <a:ext cx="3035808" cy="640080"/>
           </a:xfrm>
           <a:prstGeom prst="rect">
             <a:avLst/>
@@ -4476,29 +4430,29 @@
               <a:spcAft>
                 <a:spcPts val="700"/>
               </a:spcAft>
-              <a:defRPr sz="1000" b="1">
-                <a:solidFill>
-                  <a:srgbClr val="147D78"/>
+              <a:defRPr sz="2100" b="1">
+                <a:solidFill>
+                  <a:srgbClr val="162B43"/>
                 </a:solidFill>
                 <a:latin typeface="DejaVu Sans"/>
               </a:defRPr>
             </a:pPr>
             <a:r>
-              <a:t>ENGINEERING NEED</a:t>
-            </a:r>
-          </a:p>
-        </p:txBody>
-      </p:sp>
-      <p:sp>
-        <p:nvSpPr>
-          <p:cNvPr id="19" name="TextBox 18"/>
+              <a:t>Keep changes visible</a:t>
+            </a:r>
+          </a:p>
+        </p:txBody>
+      </p:sp>
+      <p:sp>
+        <p:nvSpPr>
+          <p:cNvPr id="17" name="TextBox 16"/>
           <p:cNvSpPr txBox="1"/>
           <p:nvPr/>
         </p:nvSpPr>
         <p:spPr>
           <a:xfrm>
-            <a:off x="8302752" y="3337560"/>
-            <a:ext cx="3035808" cy="777240"/>
+            <a:off x="8321040" y="4005072"/>
+            <a:ext cx="3035808" cy="667512"/>
           </a:xfrm>
           <a:prstGeom prst="rect">
             <a:avLst/>
@@ -4515,46 +4469,23 @@
               <a:spcAft>
                 <a:spcPts val="700"/>
               </a:spcAft>
-              <a:defRPr sz="1800" b="1">
-                <a:solidFill>
-                  <a:srgbClr val="162B43"/>
+              <a:defRPr sz="1700" b="0">
+                <a:solidFill>
+                  <a:srgbClr val="25364A"/>
                 </a:solidFill>
                 <a:latin typeface="DejaVu Sans"/>
               </a:defRPr>
             </a:pPr>
             <a:r>
-              <a:t>Explicit rules, clear decisions</a:t>
-            </a:r>
-          </a:p>
-        </p:txBody>
-      </p:sp>
-      <p:sp>
-        <p:nvSpPr>
-          <p:cNvPr id="20" name="TextBox 19"/>
-          <p:cNvSpPr txBox="1"/>
-          <p:nvPr/>
-        </p:nvSpPr>
-        <p:spPr>
-          <a:xfrm>
-            <a:off x="8302752" y="4224528"/>
-            <a:ext cx="3035808" cy="868680"/>
-          </a:xfrm>
-          <a:prstGeom prst="rect">
-            <a:avLst/>
-          </a:prstGeom>
-          <a:noFill/>
-        </p:spPr>
-        <p:txBody>
-          <a:bodyPr wrap="square" lIns="0" rIns="0" tIns="0" bIns="0">
-            <a:spAutoFit/>
-          </a:bodyPr>
-          <a:lstStyle/>
+              <a:t>Show what changed,</a:t>
+            </a:r>
+          </a:p>
           <a:p>
             <a:pPr>
               <a:spcAft>
                 <a:spcPts val="700"/>
               </a:spcAft>
-              <a:defRPr sz="1400" b="0">
+              <a:defRPr sz="1700" b="0">
                 <a:solidFill>
                   <a:srgbClr val="25364A"/>
                 </a:solidFill>
@@ -4562,21 +4493,21 @@
               </a:defRPr>
             </a:pPr>
             <a:r>
-              <a:t>Turn approved reasoning into explicit rules, versioned modules and reviewable software changes.</a:t>
-            </a:r>
-          </a:p>
-        </p:txBody>
-      </p:sp>
-      <p:sp>
-        <p:nvSpPr>
-          <p:cNvPr id="21" name="Rectangle 20"/>
+              <a:t>why, and what needs review.</a:t>
+            </a:r>
+          </a:p>
+        </p:txBody>
+      </p:sp>
+      <p:sp>
+        <p:nvSpPr>
+          <p:cNvPr id="18" name="Rectangle 17"/>
           <p:cNvSpPr/>
           <p:nvPr/>
         </p:nvSpPr>
         <p:spPr>
           <a:xfrm>
-            <a:off x="594360" y="5577840"/>
-            <a:ext cx="11000232" cy="484632"/>
+            <a:off x="594360" y="5358384"/>
+            <a:ext cx="11000232" cy="630936"/>
           </a:xfrm>
           <a:prstGeom prst="rect">
             <a:avLst/>
@@ -4612,14 +4543,14 @@
       </p:sp>
       <p:sp>
         <p:nvSpPr>
-          <p:cNvPr id="22" name="TextBox 21"/>
+          <p:cNvPr id="19" name="TextBox 18"/>
           <p:cNvSpPr txBox="1"/>
           <p:nvPr/>
         </p:nvSpPr>
         <p:spPr>
           <a:xfrm>
-            <a:off x="822960" y="5696712"/>
-            <a:ext cx="10607040" cy="256032"/>
+            <a:off x="859536" y="5559552"/>
+            <a:ext cx="10497312" cy="292608"/>
           </a:xfrm>
           <a:prstGeom prst="rect">
             <a:avLst/>
@@ -4636,7 +4567,7 @@
               <a:spcAft>
                 <a:spcPts val="700"/>
               </a:spcAft>
-              <a:defRPr sz="1400" b="1">
+              <a:defRPr sz="1700" b="1">
                 <a:solidFill>
                   <a:srgbClr val="FFFFFF"/>
                 </a:solidFill>
@@ -4644,7 +4575,7 @@
               </a:defRPr>
             </a:pPr>
             <a:r>
-              <a:t>My focus: make expert decisions explicit, preserve their sources, and test every change.</a:t>
+              <a:t>The lawyer decides. The software follows approved rules and explains its output.</a:t>
             </a:r>
           </a:p>
         </p:txBody>
@@ -4752,7 +4683,7 @@
               </a:defRPr>
             </a:pPr>
             <a:r>
-              <a:t>ARCHITECTURE · PROPOSED BOUNDARY</a:t>
+              <a:t>CHALLENGES TO EXPLORE WITH THE TEAM</a:t>
             </a:r>
           </a:p>
         </p:txBody>
@@ -4791,7 +4722,7 @@
               </a:defRPr>
             </a:pPr>
             <a:r>
-              <a:t>Rules assemble. Retrieval supports review.</a:t>
+              <a:t>Three challenges suggested by the role</a:t>
             </a:r>
           </a:p>
         </p:txBody>
@@ -4830,7 +4761,7 @@
               </a:defRPr>
             </a:pPr>
             <a:r>
-              <a:t>Legal strategy remains explicit and lawyer-approved; a language model does not select the argument.</a:t>
+              <a:t>I would confirm where these occur, and which matters most, before proposing changes.</a:t>
             </a:r>
           </a:p>
         </p:txBody>
@@ -4912,7 +4843,7 @@
               </a:defRPr>
             </a:pPr>
             <a:r>
-              <a:t>Source: supplied role description. Diagram is a proposed conceptual architecture.</a:t>
+              <a:t>Source: responsibilities in the supplied role brief. These are possible challenges, not confirmed internal faults.</a:t>
             </a:r>
           </a:p>
         </p:txBody>
@@ -4964,8 +4895,8 @@
         </p:nvSpPr>
         <p:spPr>
           <a:xfrm>
-            <a:off x="594360" y="2670048"/>
-            <a:ext cx="3383280" cy="1417320"/>
+            <a:off x="594360" y="2706624"/>
+            <a:ext cx="11000232" cy="859536"/>
           </a:xfrm>
           <a:prstGeom prst="roundRect">
             <a:avLst>
@@ -5009,8 +4940,8 @@
         </p:nvSpPr>
         <p:spPr>
           <a:xfrm>
-            <a:off x="777240" y="2871216"/>
-            <a:ext cx="3017520" cy="237744"/>
+            <a:off x="832104" y="2898648"/>
+            <a:ext cx="1527048" cy="310896"/>
           </a:xfrm>
           <a:prstGeom prst="rect">
             <a:avLst/>
@@ -5027,7 +4958,7 @@
               <a:spcAft>
                 <a:spcPts val="700"/>
               </a:spcAft>
-              <a:defRPr sz="1000" b="1">
+              <a:defRPr sz="1100" b="1">
                 <a:solidFill>
                   <a:srgbClr val="147D78"/>
                 </a:solidFill>
@@ -5035,7 +4966,7 @@
               </a:defRPr>
             </a:pPr>
             <a:r>
-              <a:t>APPROVED INPUTS</a:t>
+              <a:t>KNOWLEDGE</a:t>
             </a:r>
           </a:p>
         </p:txBody>
@@ -5048,8 +4979,8 @@
         </p:nvSpPr>
         <p:spPr>
           <a:xfrm>
-            <a:off x="777240" y="3291840"/>
-            <a:ext cx="3017520" cy="658368"/>
+            <a:off x="2532888" y="2852928"/>
+            <a:ext cx="5486400" cy="566928"/>
           </a:xfrm>
           <a:prstGeom prst="rect">
             <a:avLst/>
@@ -5066,7 +4997,7 @@
               <a:spcAft>
                 <a:spcPts val="700"/>
               </a:spcAft>
-              <a:defRPr sz="1500" b="1">
+              <a:defRPr sz="1800" b="1">
                 <a:solidFill>
                   <a:srgbClr val="162B43"/>
                 </a:solidFill>
@@ -5074,62 +5005,46 @@
               </a:defRPr>
             </a:pPr>
             <a:r>
-              <a:t>Case facts + strategy</a:t>
-            </a:r>
-          </a:p>
+              <a:t>Important reasoning may be unwritten.</a:t>
+            </a:r>
+          </a:p>
+        </p:txBody>
+      </p:sp>
+      <p:sp>
+        <p:nvSpPr>
+          <p:cNvPr id="12" name="TextBox 11"/>
+          <p:cNvSpPr txBox="1"/>
+          <p:nvPr/>
+        </p:nvSpPr>
+        <p:spPr>
+          <a:xfrm>
+            <a:off x="8247888" y="2871216"/>
+            <a:ext cx="3026664" cy="576072"/>
+          </a:xfrm>
+          <a:prstGeom prst="rect">
+            <a:avLst/>
+          </a:prstGeom>
+          <a:noFill/>
+        </p:spPr>
+        <p:txBody>
+          <a:bodyPr wrap="square" lIns="0" rIns="0" tIns="0" bIns="0">
+            <a:spAutoFit/>
+          </a:bodyPr>
+          <a:lstStyle/>
           <a:p>
             <a:pPr>
               <a:spcAft>
                 <a:spcPts val="700"/>
               </a:spcAft>
-              <a:defRPr sz="1500" b="1">
-                <a:solidFill>
-                  <a:srgbClr val="162B43"/>
+              <a:defRPr sz="1400" b="0">
+                <a:solidFill>
+                  <a:srgbClr val="25364A"/>
                 </a:solidFill>
                 <a:latin typeface="DejaVu Sans"/>
               </a:defRPr>
             </a:pPr>
             <a:r>
-              <a:t>Knowledge version</a:t>
-            </a:r>
-          </a:p>
-        </p:txBody>
-      </p:sp>
-      <p:sp>
-        <p:nvSpPr>
-          <p:cNvPr id="12" name="TextBox 11"/>
-          <p:cNvSpPr txBox="1"/>
-          <p:nvPr/>
-        </p:nvSpPr>
-        <p:spPr>
-          <a:xfrm>
-            <a:off x="4069080" y="3227832"/>
-            <a:ext cx="274320" cy="457200"/>
-          </a:xfrm>
-          <a:prstGeom prst="rect">
-            <a:avLst/>
-          </a:prstGeom>
-          <a:noFill/>
-        </p:spPr>
-        <p:txBody>
-          <a:bodyPr wrap="square" lIns="0" rIns="0" tIns="0" bIns="0">
-            <a:spAutoFit/>
-          </a:bodyPr>
-          <a:lstStyle/>
-          <a:p>
-            <a:pPr>
-              <a:spcAft>
-                <a:spcPts val="700"/>
-              </a:spcAft>
-              <a:defRPr sz="2300" b="1">
-                <a:solidFill>
-                  <a:srgbClr val="147D78"/>
-                </a:solidFill>
-                <a:latin typeface="DejaVu Sans"/>
-              </a:defRPr>
-            </a:pPr>
-            <a:r>
-              <a:t>→</a:t>
+              <a:t>Harder to reuse or hand over.</a:t>
             </a:r>
           </a:p>
         </p:txBody>
@@ -5142,8 +5057,8 @@
         </p:nvSpPr>
         <p:spPr>
           <a:xfrm>
-            <a:off x="4398264" y="2670048"/>
-            <a:ext cx="3383280" cy="1417320"/>
+            <a:off x="594360" y="3712464"/>
+            <a:ext cx="11000232" cy="859536"/>
           </a:xfrm>
           <a:prstGeom prst="roundRect">
             <a:avLst>
@@ -5187,8 +5102,8 @@
         </p:nvSpPr>
         <p:spPr>
           <a:xfrm>
-            <a:off x="4581144" y="2871216"/>
-            <a:ext cx="3017520" cy="237744"/>
+            <a:off x="832104" y="3904488"/>
+            <a:ext cx="1527048" cy="310896"/>
           </a:xfrm>
           <a:prstGeom prst="rect">
             <a:avLst/>
@@ -5205,7 +5120,7 @@
               <a:spcAft>
                 <a:spcPts val="700"/>
               </a:spcAft>
-              <a:defRPr sz="1000" b="1">
+              <a:defRPr sz="1100" b="1">
                 <a:solidFill>
                   <a:srgbClr val="147D78"/>
                 </a:solidFill>
@@ -5213,7 +5128,7 @@
               </a:defRPr>
             </a:pPr>
             <a:r>
-              <a:t>DETERMINISTIC ENGINE</a:t>
+              <a:t>CONSISTENCY</a:t>
             </a:r>
           </a:p>
         </p:txBody>
@@ -5226,8 +5141,8 @@
         </p:nvSpPr>
         <p:spPr>
           <a:xfrm>
-            <a:off x="4581144" y="3291840"/>
-            <a:ext cx="3017520" cy="658368"/>
+            <a:off x="2532888" y="3858768"/>
+            <a:ext cx="5486400" cy="566928"/>
           </a:xfrm>
           <a:prstGeom prst="rect">
             <a:avLst/>
@@ -5244,7 +5159,7 @@
               <a:spcAft>
                 <a:spcPts val="700"/>
               </a:spcAft>
-              <a:defRPr sz="1500" b="1">
+              <a:defRPr sz="1800" b="1">
                 <a:solidFill>
                   <a:srgbClr val="162B43"/>
                 </a:solidFill>
@@ -5252,62 +5167,46 @@
               </a:defRPr>
             </a:pPr>
             <a:r>
-              <a:t>Rules + dependencies</a:t>
-            </a:r>
-          </a:p>
+              <a:t>A rule change can affect earlier drafts.</a:t>
+            </a:r>
+          </a:p>
+        </p:txBody>
+      </p:sp>
+      <p:sp>
+        <p:nvSpPr>
+          <p:cNvPr id="16" name="TextBox 15"/>
+          <p:cNvSpPr txBox="1"/>
+          <p:nvPr/>
+        </p:nvSpPr>
+        <p:spPr>
+          <a:xfrm>
+            <a:off x="8247888" y="3877056"/>
+            <a:ext cx="3026664" cy="576072"/>
+          </a:xfrm>
+          <a:prstGeom prst="rect">
+            <a:avLst/>
+          </a:prstGeom>
+          <a:noFill/>
+        </p:spPr>
+        <p:txBody>
+          <a:bodyPr wrap="square" lIns="0" rIns="0" tIns="0" bIns="0">
+            <a:spAutoFit/>
+          </a:bodyPr>
+          <a:lstStyle/>
           <a:p>
             <a:pPr>
               <a:spcAft>
                 <a:spcPts val="700"/>
               </a:spcAft>
-              <a:defRPr sz="1500" b="1">
-                <a:solidFill>
-                  <a:srgbClr val="162B43"/>
+              <a:defRPr sz="1400" b="0">
+                <a:solidFill>
+                  <a:srgbClr val="25364A"/>
                 </a:solidFill>
                 <a:latin typeface="DejaVu Sans"/>
               </a:defRPr>
             </a:pPr>
             <a:r>
-              <a:t>Ordered modules</a:t>
-            </a:r>
-          </a:p>
-        </p:txBody>
-      </p:sp>
-      <p:sp>
-        <p:nvSpPr>
-          <p:cNvPr id="16" name="TextBox 15"/>
-          <p:cNvSpPr txBox="1"/>
-          <p:nvPr/>
-        </p:nvSpPr>
-        <p:spPr>
-          <a:xfrm>
-            <a:off x="7872983" y="3227832"/>
-            <a:ext cx="274320" cy="457200"/>
-          </a:xfrm>
-          <a:prstGeom prst="rect">
-            <a:avLst/>
-          </a:prstGeom>
-          <a:noFill/>
-        </p:spPr>
-        <p:txBody>
-          <a:bodyPr wrap="square" lIns="0" rIns="0" tIns="0" bIns="0">
-            <a:spAutoFit/>
-          </a:bodyPr>
-          <a:lstStyle/>
-          <a:p>
-            <a:pPr>
-              <a:spcAft>
-                <a:spcPts val="700"/>
-              </a:spcAft>
-              <a:defRPr sz="2300" b="1">
-                <a:solidFill>
-                  <a:srgbClr val="147D78"/>
-                </a:solidFill>
-                <a:latin typeface="DejaVu Sans"/>
-              </a:defRPr>
-            </a:pPr>
-            <a:r>
-              <a:t>→</a:t>
+              <a:t>Unexpected differences need checking.</a:t>
             </a:r>
           </a:p>
         </p:txBody>
@@ -5320,8 +5219,8 @@
         </p:nvSpPr>
         <p:spPr>
           <a:xfrm>
-            <a:off x="8202168" y="2670048"/>
-            <a:ext cx="3383280" cy="1417320"/>
+            <a:off x="594360" y="4718304"/>
+            <a:ext cx="11000232" cy="859536"/>
           </a:xfrm>
           <a:prstGeom prst="roundRect">
             <a:avLst>
@@ -5365,147 +5264,8 @@
         </p:nvSpPr>
         <p:spPr>
           <a:xfrm>
-            <a:off x="8385048" y="2871216"/>
-            <a:ext cx="3017520" cy="237744"/>
-          </a:xfrm>
-          <a:prstGeom prst="rect">
-            <a:avLst/>
-          </a:prstGeom>
-          <a:noFill/>
-        </p:spPr>
-        <p:txBody>
-          <a:bodyPr wrap="square" lIns="0" rIns="0" tIns="0" bIns="0">
-            <a:spAutoFit/>
-          </a:bodyPr>
-          <a:lstStyle/>
-          <a:p>
-            <a:pPr>
-              <a:spcAft>
-                <a:spcPts val="700"/>
-              </a:spcAft>
-              <a:defRPr sz="1000" b="1">
-                <a:solidFill>
-                  <a:srgbClr val="147D78"/>
-                </a:solidFill>
-                <a:latin typeface="DejaVu Sans"/>
-              </a:defRPr>
-            </a:pPr>
-            <a:r>
-              <a:t>REVIEWABLE OUTPUT</a:t>
-            </a:r>
-          </a:p>
-        </p:txBody>
-      </p:sp>
-      <p:sp>
-        <p:nvSpPr>
-          <p:cNvPr id="19" name="TextBox 18"/>
-          <p:cNvSpPr txBox="1"/>
-          <p:nvPr/>
-        </p:nvSpPr>
-        <p:spPr>
-          <a:xfrm>
-            <a:off x="8385048" y="3291840"/>
-            <a:ext cx="3017520" cy="658368"/>
-          </a:xfrm>
-          <a:prstGeom prst="rect">
-            <a:avLst/>
-          </a:prstGeom>
-          <a:noFill/>
-        </p:spPr>
-        <p:txBody>
-          <a:bodyPr wrap="square" lIns="0" rIns="0" tIns="0" bIns="0">
-            <a:spAutoFit/>
-          </a:bodyPr>
-          <a:lstStyle/>
-          <a:p>
-            <a:pPr>
-              <a:spcAft>
-                <a:spcPts val="700"/>
-              </a:spcAft>
-              <a:defRPr sz="1500" b="1">
-                <a:solidFill>
-                  <a:srgbClr val="162B43"/>
-                </a:solidFill>
-                <a:latin typeface="DejaVu Sans"/>
-              </a:defRPr>
-            </a:pPr>
-            <a:r>
-              <a:t>Draft + decision trace</a:t>
-            </a:r>
-          </a:p>
-          <a:p>
-            <a:pPr>
-              <a:spcAft>
-                <a:spcPts val="700"/>
-              </a:spcAft>
-              <a:defRPr sz="1500" b="1">
-                <a:solidFill>
-                  <a:srgbClr val="162B43"/>
-                </a:solidFill>
-                <a:latin typeface="DejaVu Sans"/>
-              </a:defRPr>
-            </a:pPr>
-            <a:r>
-              <a:t>Version + output hash</a:t>
-            </a:r>
-          </a:p>
-        </p:txBody>
-      </p:sp>
-      <p:sp>
-        <p:nvSpPr>
-          <p:cNvPr id="20" name="Rounded Rectangle 19"/>
-          <p:cNvSpPr/>
-          <p:nvPr/>
-        </p:nvSpPr>
-        <p:spPr>
-          <a:xfrm>
-            <a:off x="594360" y="4517136"/>
-            <a:ext cx="7086600" cy="1353312"/>
-          </a:xfrm>
-          <a:prstGeom prst="roundRect">
-            <a:avLst>
-              <a:gd name="adj" fmla="val 10000"/>
-            </a:avLst>
-          </a:prstGeom>
-          <a:solidFill>
-            <a:srgbClr val="162B43"/>
-          </a:solidFill>
-          <a:ln>
-            <a:noFill/>
-          </a:ln>
-        </p:spPr>
-        <p:style>
-          <a:lnRef idx="1">
-            <a:schemeClr val="accent1"/>
-          </a:lnRef>
-          <a:fillRef idx="3">
-            <a:schemeClr val="accent1"/>
-          </a:fillRef>
-          <a:effectRef idx="0">
-            <a:schemeClr val="accent1"/>
-          </a:effectRef>
-          <a:fontRef idx="minor">
-            <a:schemeClr val="lt1"/>
-          </a:fontRef>
-        </p:style>
-        <p:txBody>
-          <a:bodyPr rtlCol="0" anchor="ctr"/>
-          <a:lstStyle/>
-          <a:p>
-            <a:pPr algn="ctr"/>
-          </a:p>
-        </p:txBody>
-      </p:sp>
-      <p:sp>
-        <p:nvSpPr>
-          <p:cNvPr id="21" name="TextBox 20"/>
-          <p:cNvSpPr txBox="1"/>
-          <p:nvPr/>
-        </p:nvSpPr>
-        <p:spPr>
-          <a:xfrm>
-            <a:off x="804672" y="4727448"/>
-            <a:ext cx="6629400" cy="274320"/>
+            <a:off x="832104" y="4910328"/>
+            <a:ext cx="1527048" cy="310896"/>
           </a:xfrm>
           <a:prstGeom prst="rect">
             <a:avLst/>
@@ -5524,27 +5284,27 @@
               </a:spcAft>
               <a:defRPr sz="1100" b="1">
                 <a:solidFill>
-                  <a:srgbClr val="8DD4CB"/>
+                  <a:srgbClr val="147D78"/>
                 </a:solidFill>
                 <a:latin typeface="DejaVu Sans"/>
               </a:defRPr>
             </a:pPr>
             <a:r>
-              <a:t>SOURCE MATRIX + ASSISTIVE REVIEW</a:t>
-            </a:r>
-          </a:p>
-        </p:txBody>
-      </p:sp>
-      <p:sp>
-        <p:nvSpPr>
-          <p:cNvPr id="22" name="TextBox 21"/>
+              <a:t>SOURCES</a:t>
+            </a:r>
+          </a:p>
+        </p:txBody>
+      </p:sp>
+      <p:sp>
+        <p:nvSpPr>
+          <p:cNvPr id="19" name="TextBox 18"/>
           <p:cNvSpPr txBox="1"/>
           <p:nvPr/>
         </p:nvSpPr>
         <p:spPr>
           <a:xfrm>
-            <a:off x="804672" y="5193792"/>
-            <a:ext cx="6629400" cy="548640"/>
+            <a:off x="2532888" y="4864608"/>
+            <a:ext cx="5486400" cy="566928"/>
           </a:xfrm>
           <a:prstGeom prst="rect">
             <a:avLst/>
@@ -5561,209 +5321,54 @@
               <a:spcAft>
                 <a:spcPts val="700"/>
               </a:spcAft>
-              <a:defRPr sz="1600" b="0">
-                <a:solidFill>
-                  <a:srgbClr val="FFFFFF"/>
+              <a:defRPr sz="1800" b="1">
+                <a:solidFill>
+                  <a:srgbClr val="162B43"/>
                 </a:solidFill>
                 <a:latin typeface="DejaVu Sans"/>
               </a:defRPr>
             </a:pPr>
             <a:r>
-              <a:t>Retrieve provisions · flag missing citations</a:t>
-            </a:r>
-          </a:p>
+              <a:t>A new judgment may affect existing arguments.</a:t>
+            </a:r>
+          </a:p>
+        </p:txBody>
+      </p:sp>
+      <p:sp>
+        <p:nvSpPr>
+          <p:cNvPr id="20" name="TextBox 19"/>
+          <p:cNvSpPr txBox="1"/>
+          <p:nvPr/>
+        </p:nvSpPr>
+        <p:spPr>
+          <a:xfrm>
+            <a:off x="8247888" y="4882896"/>
+            <a:ext cx="3026664" cy="576072"/>
+          </a:xfrm>
+          <a:prstGeom prst="rect">
+            <a:avLst/>
+          </a:prstGeom>
+          <a:noFill/>
+        </p:spPr>
+        <p:txBody>
+          <a:bodyPr wrap="square" lIns="0" rIns="0" tIns="0" bIns="0">
+            <a:spAutoFit/>
+          </a:bodyPr>
+          <a:lstStyle/>
           <a:p>
             <a:pPr>
               <a:spcAft>
                 <a:spcPts val="700"/>
               </a:spcAft>
-              <a:defRPr sz="1600" b="0">
-                <a:solidFill>
-                  <a:srgbClr val="FFFFFF"/>
+              <a:defRPr sz="1400" b="0">
+                <a:solidFill>
+                  <a:srgbClr val="25364A"/>
                 </a:solidFill>
                 <a:latin typeface="DejaVu Sans"/>
               </a:defRPr>
             </a:pPr>
             <a:r>
-              <a:t>Identify modules affected by recorded judgments</a:t>
-            </a:r>
-          </a:p>
-        </p:txBody>
-      </p:sp>
-      <p:sp>
-        <p:nvSpPr>
-          <p:cNvPr id="23" name="Rounded Rectangle 22"/>
-          <p:cNvSpPr/>
-          <p:nvPr/>
-        </p:nvSpPr>
-        <p:spPr>
-          <a:xfrm>
-            <a:off x="8211312" y="4517136"/>
-            <a:ext cx="3383280" cy="1353312"/>
-          </a:xfrm>
-          <a:prstGeom prst="roundRect">
-            <a:avLst>
-              <a:gd name="adj" fmla="val 10000"/>
-            </a:avLst>
-          </a:prstGeom>
-          <a:solidFill>
-            <a:srgbClr val="E8F2EF"/>
-          </a:solidFill>
-          <a:ln>
-            <a:noFill/>
-          </a:ln>
-        </p:spPr>
-        <p:style>
-          <a:lnRef idx="1">
-            <a:schemeClr val="accent1"/>
-          </a:lnRef>
-          <a:fillRef idx="3">
-            <a:schemeClr val="accent1"/>
-          </a:fillRef>
-          <a:effectRef idx="0">
-            <a:schemeClr val="accent1"/>
-          </a:effectRef>
-          <a:fontRef idx="minor">
-            <a:schemeClr val="lt1"/>
-          </a:fontRef>
-        </p:style>
-        <p:txBody>
-          <a:bodyPr rtlCol="0" anchor="ctr"/>
-          <a:lstStyle/>
-          <a:p>
-            <a:pPr algn="ctr"/>
-          </a:p>
-        </p:txBody>
-      </p:sp>
-      <p:sp>
-        <p:nvSpPr>
-          <p:cNvPr id="24" name="TextBox 23"/>
-          <p:cNvSpPr txBox="1"/>
-          <p:nvPr/>
-        </p:nvSpPr>
-        <p:spPr>
-          <a:xfrm>
-            <a:off x="8412480" y="4727448"/>
-            <a:ext cx="2999232" cy="274320"/>
-          </a:xfrm>
-          <a:prstGeom prst="rect">
-            <a:avLst/>
-          </a:prstGeom>
-          <a:noFill/>
-        </p:spPr>
-        <p:txBody>
-          <a:bodyPr wrap="square" lIns="0" rIns="0" tIns="0" bIns="0">
-            <a:spAutoFit/>
-          </a:bodyPr>
-          <a:lstStyle/>
-          <a:p>
-            <a:pPr>
-              <a:spcAft>
-                <a:spcPts val="700"/>
-              </a:spcAft>
-              <a:defRPr sz="1100" b="1">
-                <a:solidFill>
-                  <a:srgbClr val="147D78"/>
-                </a:solidFill>
-                <a:latin typeface="DejaVu Sans"/>
-              </a:defRPr>
-            </a:pPr>
-            <a:r>
-              <a:t>LAWYER ASSESSMENT</a:t>
-            </a:r>
-          </a:p>
-        </p:txBody>
-      </p:sp>
-      <p:sp>
-        <p:nvSpPr>
-          <p:cNvPr id="25" name="TextBox 24"/>
-          <p:cNvSpPr txBox="1"/>
-          <p:nvPr/>
-        </p:nvSpPr>
-        <p:spPr>
-          <a:xfrm>
-            <a:off x="8412480" y="5193792"/>
-            <a:ext cx="2999232" cy="548640"/>
-          </a:xfrm>
-          <a:prstGeom prst="rect">
-            <a:avLst/>
-          </a:prstGeom>
-          <a:noFill/>
-        </p:spPr>
-        <p:txBody>
-          <a:bodyPr wrap="square" lIns="0" rIns="0" tIns="0" bIns="0">
-            <a:spAutoFit/>
-          </a:bodyPr>
-          <a:lstStyle/>
-          <a:p>
-            <a:pPr>
-              <a:spcAft>
-                <a:spcPts val="700"/>
-              </a:spcAft>
-              <a:defRPr sz="1500" b="1">
-                <a:solidFill>
-                  <a:srgbClr val="162B43"/>
-                </a:solidFill>
-                <a:latin typeface="DejaVu Sans"/>
-              </a:defRPr>
-            </a:pPr>
-            <a:r>
-              <a:t>Review findings</a:t>
-            </a:r>
-          </a:p>
-          <a:p>
-            <a:pPr>
-              <a:spcAft>
-                <a:spcPts val="700"/>
-              </a:spcAft>
-              <a:defRPr sz="1500" b="1">
-                <a:solidFill>
-                  <a:srgbClr val="162B43"/>
-                </a:solidFill>
-                <a:latin typeface="DejaVu Sans"/>
-              </a:defRPr>
-            </a:pPr>
-            <a:r>
-              <a:t>Assess applicability</a:t>
-            </a:r>
-          </a:p>
-        </p:txBody>
-      </p:sp>
-      <p:sp>
-        <p:nvSpPr>
-          <p:cNvPr id="26" name="TextBox 25"/>
-          <p:cNvSpPr txBox="1"/>
-          <p:nvPr/>
-        </p:nvSpPr>
-        <p:spPr>
-          <a:xfrm>
-            <a:off x="7799831" y="5010912"/>
-            <a:ext cx="301752" cy="411480"/>
-          </a:xfrm>
-          <a:prstGeom prst="rect">
-            <a:avLst/>
-          </a:prstGeom>
-          <a:noFill/>
-        </p:spPr>
-        <p:txBody>
-          <a:bodyPr wrap="square" lIns="0" rIns="0" tIns="0" bIns="0">
-            <a:spAutoFit/>
-          </a:bodyPr>
-          <a:lstStyle/>
-          <a:p>
-            <a:pPr>
-              <a:spcAft>
-                <a:spcPts val="700"/>
-              </a:spcAft>
-              <a:defRPr sz="2300" b="1">
-                <a:solidFill>
-                  <a:srgbClr val="147D78"/>
-                </a:solidFill>
-                <a:latin typeface="DejaVu Sans"/>
-              </a:defRPr>
-            </a:pPr>
-            <a:r>
-              <a:t>→</a:t>
+              <a:t>The right documents need fresh review.</a:t>
             </a:r>
           </a:p>
         </p:txBody>
@@ -5871,7 +5476,7 @@
               </a:defRPr>
             </a:pPr>
             <a:r>
-              <a:t>DAY-TO-DAY CONTRIBUTION</a:t>
+              <a:t>PROPOSED APPROACH</a:t>
             </a:r>
           </a:p>
         </p:txBody>
@@ -5910,7 +5515,7 @@
               </a:defRPr>
             </a:pPr>
             <a:r>
-              <a:t>From one approved example to one tested change</a:t>
+              <a:t>Write the rules. Check changes. Show the sources.</a:t>
             </a:r>
           </a:p>
         </p:txBody>
@@ -5949,7 +5554,7 @@
               </a:defRPr>
             </a:pPr>
             <a:r>
-              <a:t>Start with a narrow workflow and resolve ambiguity with the legal team.</a:t>
+              <a:t>Start small, and review the results with the people who do the work.</a:t>
             </a:r>
           </a:p>
         </p:txBody>
@@ -6031,7 +5636,7 @@
               </a:defRPr>
             </a:pPr>
             <a:r>
-              <a:t>Source: supplied role description. Activities and deliverables below are proposed.</a:t>
+              <a:t>Source: supplied role brief. Proposed actions and intended benefits, not claims of implemented business outcomes.</a:t>
             </a:r>
           </a:p>
         </p:txBody>
@@ -6083,8 +5688,8 @@
         </p:nvSpPr>
         <p:spPr>
           <a:xfrm>
-            <a:off x="594360" y="2587752"/>
-            <a:ext cx="438912" cy="438912"/>
+            <a:off x="594360" y="2734056"/>
+            <a:ext cx="3493008" cy="2660904"/>
           </a:xfrm>
           <a:prstGeom prst="roundRect">
             <a:avLst>
@@ -6092,7 +5697,7 @@
             </a:avLst>
           </a:prstGeom>
           <a:solidFill>
-            <a:srgbClr val="147D78"/>
+            <a:srgbClr val="F1F5F7"/>
           </a:solidFill>
           <a:ln>
             <a:noFill/>
@@ -6128,8 +5733,8 @@
         </p:nvSpPr>
         <p:spPr>
           <a:xfrm>
-            <a:off x="676656" y="2688336"/>
-            <a:ext cx="310896" cy="228600"/>
+            <a:off x="822960" y="3026664"/>
+            <a:ext cx="3035808" cy="777240"/>
           </a:xfrm>
           <a:prstGeom prst="rect">
             <a:avLst/>
@@ -6146,15 +5751,15 @@
               <a:spcAft>
                 <a:spcPts val="700"/>
               </a:spcAft>
-              <a:defRPr sz="1100" b="1">
-                <a:solidFill>
-                  <a:srgbClr val="FFFFFF"/>
+              <a:defRPr sz="2000" b="1">
+                <a:solidFill>
+                  <a:srgbClr val="162B43"/>
                 </a:solidFill>
                 <a:latin typeface="DejaVu Sans"/>
               </a:defRPr>
             </a:pPr>
             <a:r>
-              <a:t>01</a:t>
+              <a:t>Make knowledge reusable</a:t>
             </a:r>
           </a:p>
         </p:txBody>
@@ -6167,8 +5772,8 @@
         </p:nvSpPr>
         <p:spPr>
           <a:xfrm>
-            <a:off x="1243584" y="2624328"/>
-            <a:ext cx="1417320" cy="256032"/>
+            <a:off x="822960" y="4023360"/>
+            <a:ext cx="3035808" cy="841248"/>
           </a:xfrm>
           <a:prstGeom prst="rect">
             <a:avLst/>
@@ -6185,68 +5790,45 @@
               <a:spcAft>
                 <a:spcPts val="700"/>
               </a:spcAft>
-              <a:defRPr sz="1100" b="1">
-                <a:solidFill>
-                  <a:srgbClr val="147D78"/>
+              <a:defRPr sz="1600" b="0">
+                <a:solidFill>
+                  <a:srgbClr val="25364A"/>
                 </a:solidFill>
                 <a:latin typeface="DejaVu Sans"/>
               </a:defRPr>
             </a:pPr>
             <a:r>
-              <a:t>DISCOVER</a:t>
-            </a:r>
-          </a:p>
-        </p:txBody>
-      </p:sp>
-      <p:sp>
-        <p:nvSpPr>
-          <p:cNvPr id="12" name="TextBox 11"/>
-          <p:cNvSpPr txBox="1"/>
-          <p:nvPr/>
-        </p:nvSpPr>
-        <p:spPr>
-          <a:xfrm>
-            <a:off x="2788920" y="2596896"/>
-            <a:ext cx="3749039" cy="402336"/>
-          </a:xfrm>
-          <a:prstGeom prst="rect">
-            <a:avLst/>
-          </a:prstGeom>
-          <a:noFill/>
-        </p:spPr>
-        <p:txBody>
-          <a:bodyPr wrap="square" lIns="0" rIns="0" tIns="0" bIns="0">
-            <a:spAutoFit/>
-          </a:bodyPr>
-          <a:lstStyle/>
+              <a:t>Record approved paragraphs,</a:t>
+            </a:r>
+          </a:p>
           <a:p>
             <a:pPr>
               <a:spcAft>
                 <a:spcPts val="700"/>
               </a:spcAft>
-              <a:defRPr sz="1700" b="1">
-                <a:solidFill>
-                  <a:srgbClr val="162B43"/>
+              <a:defRPr sz="1600" b="0">
+                <a:solidFill>
+                  <a:srgbClr val="25364A"/>
                 </a:solidFill>
                 <a:latin typeface="DejaVu Sans"/>
               </a:defRPr>
             </a:pPr>
             <a:r>
-              <a:t>Walk through an approved pleading</a:t>
-            </a:r>
-          </a:p>
-        </p:txBody>
-      </p:sp>
-      <p:sp>
-        <p:nvSpPr>
-          <p:cNvPr id="13" name="TextBox 12"/>
+              <a:t>when to use them, and exceptions.</a:t>
+            </a:r>
+          </a:p>
+        </p:txBody>
+      </p:sp>
+      <p:sp>
+        <p:nvSpPr>
+          <p:cNvPr id="12" name="TextBox 11"/>
           <p:cNvSpPr txBox="1"/>
           <p:nvPr/>
         </p:nvSpPr>
         <p:spPr>
           <a:xfrm>
-            <a:off x="6839712" y="2578608"/>
-            <a:ext cx="4617720" cy="594360"/>
+            <a:off x="822960" y="4992624"/>
+            <a:ext cx="3035808" cy="310896"/>
           </a:xfrm>
           <a:prstGeom prst="rect">
             <a:avLst/>
@@ -6263,45 +5845,29 @@
               <a:spcAft>
                 <a:spcPts val="700"/>
               </a:spcAft>
-              <a:defRPr sz="1300" b="0">
-                <a:solidFill>
-                  <a:srgbClr val="25364A"/>
+              <a:defRPr sz="1200" b="1">
+                <a:solidFill>
+                  <a:srgbClr val="147D78"/>
                 </a:solidFill>
                 <a:latin typeface="DejaVu Sans"/>
               </a:defRPr>
             </a:pPr>
             <a:r>
-              <a:t>Capture facts, choices, exceptions</a:t>
-            </a:r>
-          </a:p>
-          <a:p>
-            <a:pPr>
-              <a:spcAft>
-                <a:spcPts val="700"/>
-              </a:spcAft>
-              <a:defRPr sz="1300" b="0">
-                <a:solidFill>
-                  <a:srgbClr val="25364A"/>
-                </a:solidFill>
-                <a:latin typeface="DejaVu Sans"/>
-              </a:defRPr>
-            </a:pPr>
-            <a:r>
-              <a:t>and open questions with a lawyer.</a:t>
-            </a:r>
-          </a:p>
-        </p:txBody>
-      </p:sp>
-      <p:sp>
-        <p:nvSpPr>
-          <p:cNvPr id="14" name="Rounded Rectangle 13"/>
+              <a:t>Benefit: clearer handovers</a:t>
+            </a:r>
+          </a:p>
+        </p:txBody>
+      </p:sp>
+      <p:sp>
+        <p:nvSpPr>
+          <p:cNvPr id="13" name="Rounded Rectangle 12"/>
           <p:cNvSpPr/>
           <p:nvPr/>
         </p:nvSpPr>
         <p:spPr>
           <a:xfrm>
-            <a:off x="594360" y="3392424"/>
-            <a:ext cx="438912" cy="438912"/>
+            <a:off x="4343400" y="2734056"/>
+            <a:ext cx="3493008" cy="2660904"/>
           </a:xfrm>
           <a:prstGeom prst="roundRect">
             <a:avLst>
@@ -6309,7 +5875,7 @@
             </a:avLst>
           </a:prstGeom>
           <a:solidFill>
-            <a:srgbClr val="147D78"/>
+            <a:srgbClr val="F1F5F7"/>
           </a:solidFill>
           <a:ln>
             <a:noFill/>
@@ -6339,14 +5905,14 @@
       </p:sp>
       <p:sp>
         <p:nvSpPr>
-          <p:cNvPr id="15" name="TextBox 14"/>
+          <p:cNvPr id="14" name="TextBox 13"/>
           <p:cNvSpPr txBox="1"/>
           <p:nvPr/>
         </p:nvSpPr>
         <p:spPr>
           <a:xfrm>
-            <a:off x="676656" y="3493008"/>
-            <a:ext cx="310896" cy="228600"/>
+            <a:off x="4572000" y="3026664"/>
+            <a:ext cx="3035808" cy="777240"/>
           </a:xfrm>
           <a:prstGeom prst="rect">
             <a:avLst/>
@@ -6363,29 +5929,29 @@
               <a:spcAft>
                 <a:spcPts val="700"/>
               </a:spcAft>
-              <a:defRPr sz="1100" b="1">
-                <a:solidFill>
-                  <a:srgbClr val="FFFFFF"/>
+              <a:defRPr sz="2000" b="1">
+                <a:solidFill>
+                  <a:srgbClr val="162B43"/>
                 </a:solidFill>
                 <a:latin typeface="DejaVu Sans"/>
               </a:defRPr>
             </a:pPr>
             <a:r>
-              <a:t>02</a:t>
-            </a:r>
-          </a:p>
-        </p:txBody>
-      </p:sp>
-      <p:sp>
-        <p:nvSpPr>
-          <p:cNvPr id="16" name="TextBox 15"/>
+              <a:t>Protect expected behavior</a:t>
+            </a:r>
+          </a:p>
+        </p:txBody>
+      </p:sp>
+      <p:sp>
+        <p:nvSpPr>
+          <p:cNvPr id="15" name="TextBox 14"/>
           <p:cNvSpPr txBox="1"/>
           <p:nvPr/>
         </p:nvSpPr>
         <p:spPr>
           <a:xfrm>
-            <a:off x="1243584" y="3429000"/>
-            <a:ext cx="1417320" cy="256032"/>
+            <a:off x="4572000" y="4023360"/>
+            <a:ext cx="3035808" cy="841248"/>
           </a:xfrm>
           <a:prstGeom prst="rect">
             <a:avLst/>
@@ -6402,68 +5968,45 @@
               <a:spcAft>
                 <a:spcPts val="700"/>
               </a:spcAft>
-              <a:defRPr sz="1100" b="1">
-                <a:solidFill>
-                  <a:srgbClr val="147D78"/>
+              <a:defRPr sz="1600" b="0">
+                <a:solidFill>
+                  <a:srgbClr val="25364A"/>
                 </a:solidFill>
                 <a:latin typeface="DejaVu Sans"/>
               </a:defRPr>
             </a:pPr>
             <a:r>
-              <a:t>FORMALISE</a:t>
-            </a:r>
-          </a:p>
-        </p:txBody>
-      </p:sp>
-      <p:sp>
-        <p:nvSpPr>
-          <p:cNvPr id="17" name="TextBox 16"/>
-          <p:cNvSpPr txBox="1"/>
-          <p:nvPr/>
-        </p:nvSpPr>
-        <p:spPr>
-          <a:xfrm>
-            <a:off x="2788920" y="3401568"/>
-            <a:ext cx="3749039" cy="402336"/>
-          </a:xfrm>
-          <a:prstGeom prst="rect">
-            <a:avLst/>
-          </a:prstGeom>
-          <a:noFill/>
-        </p:spPr>
-        <p:txBody>
-          <a:bodyPr wrap="square" lIns="0" rIns="0" tIns="0" bIns="0">
-            <a:spAutoFit/>
-          </a:bodyPr>
-          <a:lstStyle/>
+              <a:t>Rerun agreed examples</a:t>
+            </a:r>
+          </a:p>
           <a:p>
             <a:pPr>
               <a:spcAft>
                 <a:spcPts val="700"/>
               </a:spcAft>
-              <a:defRPr sz="1700" b="1">
-                <a:solidFill>
-                  <a:srgbClr val="162B43"/>
+              <a:defRPr sz="1600" b="0">
+                <a:solidFill>
+                  <a:srgbClr val="25364A"/>
                 </a:solidFill>
                 <a:latin typeface="DejaVu Sans"/>
               </a:defRPr>
             </a:pPr>
             <a:r>
-              <a:t>Make the rules inspectable</a:t>
-            </a:r>
-          </a:p>
-        </p:txBody>
-      </p:sp>
-      <p:sp>
-        <p:nvSpPr>
-          <p:cNvPr id="18" name="TextBox 17"/>
+              <a:t>whenever rules change.</a:t>
+            </a:r>
+          </a:p>
+        </p:txBody>
+      </p:sp>
+      <p:sp>
+        <p:nvSpPr>
+          <p:cNvPr id="16" name="TextBox 15"/>
           <p:cNvSpPr txBox="1"/>
           <p:nvPr/>
         </p:nvSpPr>
         <p:spPr>
           <a:xfrm>
-            <a:off x="6839712" y="3383280"/>
-            <a:ext cx="4617720" cy="594360"/>
+            <a:off x="4572000" y="4992624"/>
+            <a:ext cx="3035808" cy="310896"/>
           </a:xfrm>
           <a:prstGeom prst="rect">
             <a:avLst/>
@@ -6480,45 +6023,29 @@
               <a:spcAft>
                 <a:spcPts val="700"/>
               </a:spcAft>
-              <a:defRPr sz="1300" b="0">
-                <a:solidFill>
-                  <a:srgbClr val="25364A"/>
+              <a:defRPr sz="1200" b="1">
+                <a:solidFill>
+                  <a:srgbClr val="147D78"/>
                 </a:solidFill>
                 <a:latin typeface="DejaVu Sans"/>
               </a:defRPr>
             </a:pPr>
             <a:r>
-              <a:t>Define module conditions and links</a:t>
-            </a:r>
-          </a:p>
-          <a:p>
-            <a:pPr>
-              <a:spcAft>
-                <a:spcPts val="700"/>
-              </a:spcAft>
-              <a:defRPr sz="1300" b="0">
-                <a:solidFill>
-                  <a:srgbClr val="25364A"/>
-                </a:solidFill>
-                <a:latin typeface="DejaVu Sans"/>
-              </a:defRPr>
-            </a:pPr>
-            <a:r>
-              <a:t>in a structured schema.</a:t>
-            </a:r>
-          </a:p>
-        </p:txBody>
-      </p:sp>
-      <p:sp>
-        <p:nvSpPr>
-          <p:cNvPr id="19" name="Rounded Rectangle 18"/>
+              <a:t>Benefit: fewer silent surprises</a:t>
+            </a:r>
+          </a:p>
+        </p:txBody>
+      </p:sp>
+      <p:sp>
+        <p:nvSpPr>
+          <p:cNvPr id="17" name="Rounded Rectangle 16"/>
           <p:cNvSpPr/>
           <p:nvPr/>
         </p:nvSpPr>
         <p:spPr>
           <a:xfrm>
-            <a:off x="594360" y="4197096"/>
-            <a:ext cx="438912" cy="438912"/>
+            <a:off x="8092440" y="2734056"/>
+            <a:ext cx="3493008" cy="2660904"/>
           </a:xfrm>
           <a:prstGeom prst="roundRect">
             <a:avLst>
@@ -6526,7 +6053,7 @@
             </a:avLst>
           </a:prstGeom>
           <a:solidFill>
-            <a:srgbClr val="147D78"/>
+            <a:srgbClr val="F1F5F7"/>
           </a:solidFill>
           <a:ln>
             <a:noFill/>
@@ -6556,14 +6083,14 @@
       </p:sp>
       <p:sp>
         <p:nvSpPr>
-          <p:cNvPr id="20" name="TextBox 19"/>
+          <p:cNvPr id="18" name="TextBox 17"/>
           <p:cNvSpPr txBox="1"/>
           <p:nvPr/>
         </p:nvSpPr>
         <p:spPr>
           <a:xfrm>
-            <a:off x="676656" y="4297680"/>
-            <a:ext cx="310896" cy="228600"/>
+            <a:off x="8321040" y="3026664"/>
+            <a:ext cx="3035808" cy="777240"/>
           </a:xfrm>
           <a:prstGeom prst="rect">
             <a:avLst/>
@@ -6580,29 +6107,29 @@
               <a:spcAft>
                 <a:spcPts val="700"/>
               </a:spcAft>
-              <a:defRPr sz="1100" b="1">
-                <a:solidFill>
-                  <a:srgbClr val="FFFFFF"/>
+              <a:defRPr sz="2000" b="1">
+                <a:solidFill>
+                  <a:srgbClr val="162B43"/>
                 </a:solidFill>
                 <a:latin typeface="DejaVu Sans"/>
               </a:defRPr>
             </a:pPr>
             <a:r>
-              <a:t>03</a:t>
-            </a:r>
-          </a:p>
-        </p:txBody>
-      </p:sp>
-      <p:sp>
-        <p:nvSpPr>
-          <p:cNvPr id="21" name="TextBox 20"/>
+              <a:t>Support legal review</a:t>
+            </a:r>
+          </a:p>
+        </p:txBody>
+      </p:sp>
+      <p:sp>
+        <p:nvSpPr>
+          <p:cNvPr id="19" name="TextBox 18"/>
           <p:cNvSpPr txBox="1"/>
           <p:nvPr/>
         </p:nvSpPr>
         <p:spPr>
           <a:xfrm>
-            <a:off x="1243584" y="4233672"/>
-            <a:ext cx="1417320" cy="256032"/>
+            <a:off x="8321040" y="4023360"/>
+            <a:ext cx="3035808" cy="841248"/>
           </a:xfrm>
           <a:prstGeom prst="rect">
             <a:avLst/>
@@ -6619,68 +6146,45 @@
               <a:spcAft>
                 <a:spcPts val="700"/>
               </a:spcAft>
-              <a:defRPr sz="1100" b="1">
-                <a:solidFill>
-                  <a:srgbClr val="147D78"/>
+              <a:defRPr sz="1600" b="0">
+                <a:solidFill>
+                  <a:srgbClr val="25364A"/>
                 </a:solidFill>
                 <a:latin typeface="DejaVu Sans"/>
               </a:defRPr>
             </a:pPr>
             <a:r>
-              <a:t>IMPLEMENT</a:t>
-            </a:r>
-          </a:p>
-        </p:txBody>
-      </p:sp>
-      <p:sp>
-        <p:nvSpPr>
-          <p:cNvPr id="22" name="TextBox 21"/>
-          <p:cNvSpPr txBox="1"/>
-          <p:nvPr/>
-        </p:nvSpPr>
-        <p:spPr>
-          <a:xfrm>
-            <a:off x="2788920" y="4206240"/>
-            <a:ext cx="3749039" cy="402336"/>
-          </a:xfrm>
-          <a:prstGeom prst="rect">
-            <a:avLst/>
-          </a:prstGeom>
-          <a:noFill/>
-        </p:spPr>
-        <p:txBody>
-          <a:bodyPr wrap="square" lIns="0" rIns="0" tIns="0" bIns="0">
-            <a:spAutoFit/>
-          </a:bodyPr>
-          <a:lstStyle/>
+              <a:t>Link paragraphs to sources</a:t>
+            </a:r>
+          </a:p>
           <a:p>
             <a:pPr>
               <a:spcAft>
                 <a:spcPts val="700"/>
               </a:spcAft>
-              <a:defRPr sz="1700" b="1">
-                <a:solidFill>
-                  <a:srgbClr val="162B43"/>
+              <a:defRPr sz="1600" b="0">
+                <a:solidFill>
+                  <a:srgbClr val="25364A"/>
                 </a:solidFill>
                 <a:latin typeface="DejaVu Sans"/>
               </a:defRPr>
             </a:pPr>
             <a:r>
-              <a:t>Change one bounded behavior</a:t>
-            </a:r>
-          </a:p>
-        </p:txBody>
-      </p:sp>
-      <p:sp>
-        <p:nvSpPr>
-          <p:cNvPr id="23" name="TextBox 22"/>
+              <a:t>and flag possible update impacts.</a:t>
+            </a:r>
+          </a:p>
+        </p:txBody>
+      </p:sp>
+      <p:sp>
+        <p:nvSpPr>
+          <p:cNvPr id="20" name="TextBox 19"/>
           <p:cNvSpPr txBox="1"/>
           <p:nvPr/>
         </p:nvSpPr>
         <p:spPr>
           <a:xfrm>
-            <a:off x="6839712" y="4187952"/>
-            <a:ext cx="4617720" cy="594360"/>
+            <a:off x="8321040" y="4992624"/>
+            <a:ext cx="3035808" cy="310896"/>
           </a:xfrm>
           <a:prstGeom prst="rect">
             <a:avLst/>
@@ -6697,330 +6201,54 @@
               <a:spcAft>
                 <a:spcPts val="700"/>
               </a:spcAft>
-              <a:defRPr sz="1300" b="0">
-                <a:solidFill>
-                  <a:srgbClr val="25364A"/>
+              <a:defRPr sz="1200" b="1">
+                <a:solidFill>
+                  <a:srgbClr val="147D78"/>
                 </a:solidFill>
                 <a:latin typeface="DejaVu Sans"/>
               </a:defRPr>
             </a:pPr>
             <a:r>
-              <a:t>Update Python logic and preserve</a:t>
-            </a:r>
-          </a:p>
+              <a:t>Benefit: focused source checking</a:t>
+            </a:r>
+          </a:p>
+        </p:txBody>
+      </p:sp>
+      <p:sp>
+        <p:nvSpPr>
+          <p:cNvPr id="21" name="TextBox 20"/>
+          <p:cNvSpPr txBox="1"/>
+          <p:nvPr/>
+        </p:nvSpPr>
+        <p:spPr>
+          <a:xfrm>
+            <a:off x="594360" y="5760720"/>
+            <a:ext cx="10972800" cy="320040"/>
+          </a:xfrm>
+          <a:prstGeom prst="rect">
+            <a:avLst/>
+          </a:prstGeom>
+          <a:noFill/>
+        </p:spPr>
+        <p:txBody>
+          <a:bodyPr wrap="square" lIns="0" rIns="0" tIns="0" bIns="0">
+            <a:spAutoFit/>
+          </a:bodyPr>
+          <a:lstStyle/>
           <a:p>
             <a:pPr>
               <a:spcAft>
                 <a:spcPts val="700"/>
               </a:spcAft>
-              <a:defRPr sz="1300" b="0">
-                <a:solidFill>
-                  <a:srgbClr val="25364A"/>
+              <a:defRPr sz="1600" b="1">
+                <a:solidFill>
+                  <a:srgbClr val="162B43"/>
                 </a:solidFill>
                 <a:latin typeface="DejaVu Sans"/>
               </a:defRPr>
             </a:pPr>
             <a:r>
-              <a:t>versions and decision traces.</a:t>
-            </a:r>
-          </a:p>
-        </p:txBody>
-      </p:sp>
-      <p:sp>
-        <p:nvSpPr>
-          <p:cNvPr id="24" name="Rounded Rectangle 23"/>
-          <p:cNvSpPr/>
-          <p:nvPr/>
-        </p:nvSpPr>
-        <p:spPr>
-          <a:xfrm>
-            <a:off x="594360" y="5001768"/>
-            <a:ext cx="438912" cy="438912"/>
-          </a:xfrm>
-          <a:prstGeom prst="roundRect">
-            <a:avLst>
-              <a:gd name="adj" fmla="val 10000"/>
-            </a:avLst>
-          </a:prstGeom>
-          <a:solidFill>
-            <a:srgbClr val="147D78"/>
-          </a:solidFill>
-          <a:ln>
-            <a:noFill/>
-          </a:ln>
-        </p:spPr>
-        <p:style>
-          <a:lnRef idx="1">
-            <a:schemeClr val="accent1"/>
-          </a:lnRef>
-          <a:fillRef idx="3">
-            <a:schemeClr val="accent1"/>
-          </a:fillRef>
-          <a:effectRef idx="0">
-            <a:schemeClr val="accent1"/>
-          </a:effectRef>
-          <a:fontRef idx="minor">
-            <a:schemeClr val="lt1"/>
-          </a:fontRef>
-        </p:style>
-        <p:txBody>
-          <a:bodyPr rtlCol="0" anchor="ctr"/>
-          <a:lstStyle/>
-          <a:p>
-            <a:pPr algn="ctr"/>
-          </a:p>
-        </p:txBody>
-      </p:sp>
-      <p:sp>
-        <p:nvSpPr>
-          <p:cNvPr id="25" name="TextBox 24"/>
-          <p:cNvSpPr txBox="1"/>
-          <p:nvPr/>
-        </p:nvSpPr>
-        <p:spPr>
-          <a:xfrm>
-            <a:off x="676656" y="5102352"/>
-            <a:ext cx="310896" cy="228600"/>
-          </a:xfrm>
-          <a:prstGeom prst="rect">
-            <a:avLst/>
-          </a:prstGeom>
-          <a:noFill/>
-        </p:spPr>
-        <p:txBody>
-          <a:bodyPr wrap="square" lIns="0" rIns="0" tIns="0" bIns="0">
-            <a:spAutoFit/>
-          </a:bodyPr>
-          <a:lstStyle/>
-          <a:p>
-            <a:pPr>
-              <a:spcAft>
-                <a:spcPts val="700"/>
-              </a:spcAft>
-              <a:defRPr sz="1100" b="1">
-                <a:solidFill>
-                  <a:srgbClr val="FFFFFF"/>
-                </a:solidFill>
-                <a:latin typeface="DejaVu Sans"/>
-              </a:defRPr>
-            </a:pPr>
-            <a:r>
-              <a:t>04</a:t>
-            </a:r>
-          </a:p>
-        </p:txBody>
-      </p:sp>
-      <p:sp>
-        <p:nvSpPr>
-          <p:cNvPr id="26" name="TextBox 25"/>
-          <p:cNvSpPr txBox="1"/>
-          <p:nvPr/>
-        </p:nvSpPr>
-        <p:spPr>
-          <a:xfrm>
-            <a:off x="1243584" y="5038344"/>
-            <a:ext cx="1417320" cy="256032"/>
-          </a:xfrm>
-          <a:prstGeom prst="rect">
-            <a:avLst/>
-          </a:prstGeom>
-          <a:noFill/>
-        </p:spPr>
-        <p:txBody>
-          <a:bodyPr wrap="square" lIns="0" rIns="0" tIns="0" bIns="0">
-            <a:spAutoFit/>
-          </a:bodyPr>
-          <a:lstStyle/>
-          <a:p>
-            <a:pPr>
-              <a:spcAft>
-                <a:spcPts val="700"/>
-              </a:spcAft>
-              <a:defRPr sz="1100" b="1">
-                <a:solidFill>
-                  <a:srgbClr val="147D78"/>
-                </a:solidFill>
-                <a:latin typeface="DejaVu Sans"/>
-              </a:defRPr>
-            </a:pPr>
-            <a:r>
-              <a:t>VALIDATE</a:t>
-            </a:r>
-          </a:p>
-        </p:txBody>
-      </p:sp>
-      <p:sp>
-        <p:nvSpPr>
-          <p:cNvPr id="27" name="TextBox 26"/>
-          <p:cNvSpPr txBox="1"/>
-          <p:nvPr/>
-        </p:nvSpPr>
-        <p:spPr>
-          <a:xfrm>
-            <a:off x="2788920" y="5010912"/>
-            <a:ext cx="3749039" cy="402336"/>
-          </a:xfrm>
-          <a:prstGeom prst="rect">
-            <a:avLst/>
-          </a:prstGeom>
-          <a:noFill/>
-        </p:spPr>
-        <p:txBody>
-          <a:bodyPr wrap="square" lIns="0" rIns="0" tIns="0" bIns="0">
-            <a:spAutoFit/>
-          </a:bodyPr>
-          <a:lstStyle/>
-          <a:p>
-            <a:pPr>
-              <a:spcAft>
-                <a:spcPts val="700"/>
-              </a:spcAft>
-              <a:defRPr sz="1700" b="1">
-                <a:solidFill>
-                  <a:srgbClr val="162B43"/>
-                </a:solidFill>
-                <a:latin typeface="DejaVu Sans"/>
-              </a:defRPr>
-            </a:pPr>
-            <a:r>
-              <a:t>Review evidence before release</a:t>
-            </a:r>
-          </a:p>
-        </p:txBody>
-      </p:sp>
-      <p:sp>
-        <p:nvSpPr>
-          <p:cNvPr id="28" name="TextBox 27"/>
-          <p:cNvSpPr txBox="1"/>
-          <p:nvPr/>
-        </p:nvSpPr>
-        <p:spPr>
-          <a:xfrm>
-            <a:off x="6839712" y="4992624"/>
-            <a:ext cx="4617720" cy="594360"/>
-          </a:xfrm>
-          <a:prstGeom prst="rect">
-            <a:avLst/>
-          </a:prstGeom>
-          <a:noFill/>
-        </p:spPr>
-        <p:txBody>
-          <a:bodyPr wrap="square" lIns="0" rIns="0" tIns="0" bIns="0">
-            <a:spAutoFit/>
-          </a:bodyPr>
-          <a:lstStyle/>
-          <a:p>
-            <a:pPr>
-              <a:spcAft>
-                <a:spcPts val="700"/>
-              </a:spcAft>
-              <a:defRPr sz="1300" b="0">
-                <a:solidFill>
-                  <a:srgbClr val="25364A"/>
-                </a:solidFill>
-                <a:latin typeface="DejaVu Sans"/>
-              </a:defRPr>
-            </a:pPr>
-            <a:r>
-              <a:t>Compare expected outputs, explain</a:t>
-            </a:r>
-          </a:p>
-          <a:p>
-            <a:pPr>
-              <a:spcAft>
-                <a:spcPts val="700"/>
-              </a:spcAft>
-              <a:defRPr sz="1300" b="0">
-                <a:solidFill>
-                  <a:srgbClr val="25364A"/>
-                </a:solidFill>
-                <a:latin typeface="DejaVu Sans"/>
-              </a:defRPr>
-            </a:pPr>
-            <a:r>
-              <a:t>differences and record approval.</a:t>
-            </a:r>
-          </a:p>
-        </p:txBody>
-      </p:sp>
-      <p:sp>
-        <p:nvSpPr>
-          <p:cNvPr id="29" name="Rectangle 28"/>
-          <p:cNvSpPr/>
-          <p:nvPr/>
-        </p:nvSpPr>
-        <p:spPr>
-          <a:xfrm>
-            <a:off x="594360" y="5934456"/>
-            <a:ext cx="11000232" cy="274320"/>
-          </a:xfrm>
-          <a:prstGeom prst="rect">
-            <a:avLst/>
-          </a:prstGeom>
-          <a:solidFill>
-            <a:srgbClr val="F1F5F7"/>
-          </a:solidFill>
-          <a:ln>
-            <a:noFill/>
-          </a:ln>
-        </p:spPr>
-        <p:style>
-          <a:lnRef idx="1">
-            <a:schemeClr val="accent1"/>
-          </a:lnRef>
-          <a:fillRef idx="3">
-            <a:schemeClr val="accent1"/>
-          </a:fillRef>
-          <a:effectRef idx="0">
-            <a:schemeClr val="accent1"/>
-          </a:effectRef>
-          <a:fontRef idx="minor">
-            <a:schemeClr val="lt1"/>
-          </a:fontRef>
-        </p:style>
-        <p:txBody>
-          <a:bodyPr rtlCol="0" anchor="ctr"/>
-          <a:lstStyle/>
-          <a:p>
-            <a:pPr algn="ctr"/>
-          </a:p>
-        </p:txBody>
-      </p:sp>
-      <p:sp>
-        <p:nvSpPr>
-          <p:cNvPr id="30" name="TextBox 29"/>
-          <p:cNvSpPr txBox="1"/>
-          <p:nvPr/>
-        </p:nvSpPr>
-        <p:spPr>
-          <a:xfrm>
-            <a:off x="749808" y="5961888"/>
-            <a:ext cx="10698480" cy="201168"/>
-          </a:xfrm>
-          <a:prstGeom prst="rect">
-            <a:avLst/>
-          </a:prstGeom>
-          <a:noFill/>
-        </p:spPr>
-        <p:txBody>
-          <a:bodyPr wrap="square" lIns="0" rIns="0" tIns="0" bIns="0">
-            <a:spAutoFit/>
-          </a:bodyPr>
-          <a:lstStyle/>
-          <a:p>
-            <a:pPr>
-              <a:spcAft>
-                <a:spcPts val="700"/>
-              </a:spcAft>
-              <a:defRPr sz="1100" b="0">
-                <a:solidFill>
-                  <a:srgbClr val="607185"/>
-                </a:solidFill>
-                <a:latin typeface="DejaVu Sans"/>
-              </a:defRPr>
-            </a:pPr>
-            <a:r>
-              <a:t>Python + structured data + Git; use formal constraint checks where they add value.</a:t>
+              <a:t>AI can suggest checks and retrieve material. It does not choose the legal strategy.</a:t>
             </a:r>
           </a:p>
         </p:txBody>
@@ -7128,7 +6356,7 @@
               </a:defRPr>
             </a:pPr>
             <a:r>
-              <a:t>VALIDATION · IMPACT ANALYSIS</a:t>
+              <a:t>ILLUSTRATIVE EXAMPLE</a:t>
             </a:r>
           </a:p>
         </p:txBody>
@@ -7167,7 +6395,7 @@
               </a:defRPr>
             </a:pPr>
             <a:r>
-              <a:t>A source update should trigger a reviewable change</a:t>
+              <a:t>A new judgment arrives. What happens next?</a:t>
             </a:r>
           </a:p>
         </p:txBody>
@@ -7206,7 +6434,7 @@
               </a:defRPr>
             </a:pPr>
             <a:r>
-              <a:t>Example: a new judgment is linked to a provision already used by document modules.</a:t>
+              <a:t>Identify what may be affected before changing an approved drafting rule.</a:t>
             </a:r>
           </a:p>
         </p:txBody>
@@ -7288,7 +6516,7 @@
               </a:defRPr>
             </a:pPr>
             <a:r>
-              <a:t>Source: supplied role description; illustrative update, not a real judgment or legal conclusion.</a:t>
+              <a:t>Illustration only: no real judgment, case or legal conclusion. Approved examples would be supplied by the team.</a:t>
             </a:r>
           </a:p>
         </p:txBody>
@@ -7340,8 +6568,8 @@
         </p:nvSpPr>
         <p:spPr>
           <a:xfrm>
-            <a:off x="594360" y="2624328"/>
-            <a:ext cx="2560320" cy="1463040"/>
+            <a:off x="594360" y="2825496"/>
+            <a:ext cx="2560320" cy="1810512"/>
           </a:xfrm>
           <a:prstGeom prst="roundRect">
             <a:avLst>
@@ -7385,8 +6613,102 @@
         </p:nvSpPr>
         <p:spPr>
           <a:xfrm>
-            <a:off x="758952" y="2834640"/>
-            <a:ext cx="2231136" cy="320040"/>
+            <a:off x="777240" y="3108960"/>
+            <a:ext cx="2194560" cy="658368"/>
+          </a:xfrm>
+          <a:prstGeom prst="rect">
+            <a:avLst/>
+          </a:prstGeom>
+          <a:noFill/>
+        </p:spPr>
+        <p:txBody>
+          <a:bodyPr wrap="square" lIns="0" rIns="0" tIns="0" bIns="0">
+            <a:spAutoFit/>
+          </a:bodyPr>
+          <a:lstStyle/>
+          <a:p>
+            <a:pPr>
+              <a:spcAft>
+                <a:spcPts val="700"/>
+              </a:spcAft>
+              <a:defRPr sz="1800" b="1">
+                <a:solidFill>
+                  <a:srgbClr val="162B43"/>
+                </a:solidFill>
+                <a:latin typeface="DejaVu Sans"/>
+              </a:defRPr>
+            </a:pPr>
+            <a:r>
+              <a:t>1. Record it</a:t>
+            </a:r>
+          </a:p>
+        </p:txBody>
+      </p:sp>
+      <p:sp>
+        <p:nvSpPr>
+          <p:cNvPr id="11" name="TextBox 10"/>
+          <p:cNvSpPr txBox="1"/>
+          <p:nvPr/>
+        </p:nvSpPr>
+        <p:spPr>
+          <a:xfrm>
+            <a:off x="777240" y="3904487"/>
+            <a:ext cx="2194560" cy="594360"/>
+          </a:xfrm>
+          <a:prstGeom prst="rect">
+            <a:avLst/>
+          </a:prstGeom>
+          <a:noFill/>
+        </p:spPr>
+        <p:txBody>
+          <a:bodyPr wrap="square" lIns="0" rIns="0" tIns="0" bIns="0">
+            <a:spAutoFit/>
+          </a:bodyPr>
+          <a:lstStyle/>
+          <a:p>
+            <a:pPr>
+              <a:spcAft>
+                <a:spcPts val="700"/>
+              </a:spcAft>
+              <a:defRPr sz="1500" b="0">
+                <a:solidFill>
+                  <a:srgbClr val="25364A"/>
+                </a:solidFill>
+                <a:latin typeface="DejaVu Sans"/>
+              </a:defRPr>
+            </a:pPr>
+            <a:r>
+              <a:t>Save the source</a:t>
+            </a:r>
+          </a:p>
+          <a:p>
+            <a:pPr>
+              <a:spcAft>
+                <a:spcPts val="700"/>
+              </a:spcAft>
+              <a:defRPr sz="1500" b="0">
+                <a:solidFill>
+                  <a:srgbClr val="25364A"/>
+                </a:solidFill>
+                <a:latin typeface="DejaVu Sans"/>
+              </a:defRPr>
+            </a:pPr>
+            <a:r>
+              <a:t>and its date.</a:t>
+            </a:r>
+          </a:p>
+        </p:txBody>
+      </p:sp>
+      <p:sp>
+        <p:nvSpPr>
+          <p:cNvPr id="12" name="TextBox 11"/>
+          <p:cNvSpPr txBox="1"/>
+          <p:nvPr/>
+        </p:nvSpPr>
+        <p:spPr>
+          <a:xfrm>
+            <a:off x="3209544" y="3602736"/>
+            <a:ext cx="219456" cy="310896"/>
           </a:xfrm>
           <a:prstGeom prst="rect">
             <a:avLst/>
@@ -7405,100 +6727,6 @@
               </a:spcAft>
               <a:defRPr sz="1700" b="1">
                 <a:solidFill>
-                  <a:srgbClr val="162B43"/>
-                </a:solidFill>
-                <a:latin typeface="DejaVu Sans"/>
-              </a:defRPr>
-            </a:pPr>
-            <a:r>
-              <a:t>Record source</a:t>
-            </a:r>
-          </a:p>
-        </p:txBody>
-      </p:sp>
-      <p:sp>
-        <p:nvSpPr>
-          <p:cNvPr id="11" name="TextBox 10"/>
-          <p:cNvSpPr txBox="1"/>
-          <p:nvPr/>
-        </p:nvSpPr>
-        <p:spPr>
-          <a:xfrm>
-            <a:off x="758952" y="3364992"/>
-            <a:ext cx="2231136" cy="566928"/>
-          </a:xfrm>
-          <a:prstGeom prst="rect">
-            <a:avLst/>
-          </a:prstGeom>
-          <a:noFill/>
-        </p:spPr>
-        <p:txBody>
-          <a:bodyPr wrap="square" lIns="0" rIns="0" tIns="0" bIns="0">
-            <a:spAutoFit/>
-          </a:bodyPr>
-          <a:lstStyle/>
-          <a:p>
-            <a:pPr>
-              <a:spcAft>
-                <a:spcPts val="700"/>
-              </a:spcAft>
-              <a:defRPr sz="1300" b="0">
-                <a:solidFill>
-                  <a:srgbClr val="25364A"/>
-                </a:solidFill>
-                <a:latin typeface="DejaVu Sans"/>
-              </a:defRPr>
-            </a:pPr>
-            <a:r>
-              <a:t>Authority, date,</a:t>
-            </a:r>
-          </a:p>
-          <a:p>
-            <a:pPr>
-              <a:spcAft>
-                <a:spcPts val="700"/>
-              </a:spcAft>
-              <a:defRPr sz="1300" b="0">
-                <a:solidFill>
-                  <a:srgbClr val="25364A"/>
-                </a:solidFill>
-                <a:latin typeface="DejaVu Sans"/>
-              </a:defRPr>
-            </a:pPr>
-            <a:r>
-              <a:t>jurisdiction, version</a:t>
-            </a:r>
-          </a:p>
-        </p:txBody>
-      </p:sp>
-      <p:sp>
-        <p:nvSpPr>
-          <p:cNvPr id="12" name="TextBox 11"/>
-          <p:cNvSpPr txBox="1"/>
-          <p:nvPr/>
-        </p:nvSpPr>
-        <p:spPr>
-          <a:xfrm>
-            <a:off x="3209544" y="3163824"/>
-            <a:ext cx="219456" cy="310896"/>
-          </a:xfrm>
-          <a:prstGeom prst="rect">
-            <a:avLst/>
-          </a:prstGeom>
-          <a:noFill/>
-        </p:spPr>
-        <p:txBody>
-          <a:bodyPr wrap="square" lIns="0" rIns="0" tIns="0" bIns="0">
-            <a:spAutoFit/>
-          </a:bodyPr>
-          <a:lstStyle/>
-          <a:p>
-            <a:pPr>
-              <a:spcAft>
-                <a:spcPts val="700"/>
-              </a:spcAft>
-              <a:defRPr sz="1600" b="1">
-                <a:solidFill>
                   <a:srgbClr val="147D78"/>
                 </a:solidFill>
                 <a:latin typeface="DejaVu Sans"/>
@@ -7518,8 +6746,8 @@
         </p:nvSpPr>
         <p:spPr>
           <a:xfrm>
-            <a:off x="3410712" y="2624328"/>
-            <a:ext cx="2560320" cy="1463040"/>
+            <a:off x="3410712" y="2825496"/>
+            <a:ext cx="2560320" cy="1810512"/>
           </a:xfrm>
           <a:prstGeom prst="roundRect">
             <a:avLst>
@@ -7563,8 +6791,102 @@
         </p:nvSpPr>
         <p:spPr>
           <a:xfrm>
-            <a:off x="3575304" y="2834640"/>
-            <a:ext cx="2231136" cy="320040"/>
+            <a:off x="3593592" y="3108960"/>
+            <a:ext cx="2194560" cy="658368"/>
+          </a:xfrm>
+          <a:prstGeom prst="rect">
+            <a:avLst/>
+          </a:prstGeom>
+          <a:noFill/>
+        </p:spPr>
+        <p:txBody>
+          <a:bodyPr wrap="square" lIns="0" rIns="0" tIns="0" bIns="0">
+            <a:spAutoFit/>
+          </a:bodyPr>
+          <a:lstStyle/>
+          <a:p>
+            <a:pPr>
+              <a:spcAft>
+                <a:spcPts val="700"/>
+              </a:spcAft>
+              <a:defRPr sz="1800" b="1">
+                <a:solidFill>
+                  <a:srgbClr val="162B43"/>
+                </a:solidFill>
+                <a:latin typeface="DejaVu Sans"/>
+              </a:defRPr>
+            </a:pPr>
+            <a:r>
+              <a:t>2. Find links</a:t>
+            </a:r>
+          </a:p>
+        </p:txBody>
+      </p:sp>
+      <p:sp>
+        <p:nvSpPr>
+          <p:cNvPr id="15" name="TextBox 14"/>
+          <p:cNvSpPr txBox="1"/>
+          <p:nvPr/>
+        </p:nvSpPr>
+        <p:spPr>
+          <a:xfrm>
+            <a:off x="3593592" y="3904487"/>
+            <a:ext cx="2194560" cy="594360"/>
+          </a:xfrm>
+          <a:prstGeom prst="rect">
+            <a:avLst/>
+          </a:prstGeom>
+          <a:noFill/>
+        </p:spPr>
+        <p:txBody>
+          <a:bodyPr wrap="square" lIns="0" rIns="0" tIns="0" bIns="0">
+            <a:spAutoFit/>
+          </a:bodyPr>
+          <a:lstStyle/>
+          <a:p>
+            <a:pPr>
+              <a:spcAft>
+                <a:spcPts val="700"/>
+              </a:spcAft>
+              <a:defRPr sz="1500" b="0">
+                <a:solidFill>
+                  <a:srgbClr val="25364A"/>
+                </a:solidFill>
+                <a:latin typeface="DejaVu Sans"/>
+              </a:defRPr>
+            </a:pPr>
+            <a:r>
+              <a:t>List paragraphs</a:t>
+            </a:r>
+          </a:p>
+          <a:p>
+            <a:pPr>
+              <a:spcAft>
+                <a:spcPts val="700"/>
+              </a:spcAft>
+              <a:defRPr sz="1500" b="0">
+                <a:solidFill>
+                  <a:srgbClr val="25364A"/>
+                </a:solidFill>
+                <a:latin typeface="DejaVu Sans"/>
+              </a:defRPr>
+            </a:pPr>
+            <a:r>
+              <a:t>that may be affected.</a:t>
+            </a:r>
+          </a:p>
+        </p:txBody>
+      </p:sp>
+      <p:sp>
+        <p:nvSpPr>
+          <p:cNvPr id="16" name="TextBox 15"/>
+          <p:cNvSpPr txBox="1"/>
+          <p:nvPr/>
+        </p:nvSpPr>
+        <p:spPr>
+          <a:xfrm>
+            <a:off x="6025896" y="3602736"/>
+            <a:ext cx="219456" cy="310896"/>
           </a:xfrm>
           <a:prstGeom prst="rect">
             <a:avLst/>
@@ -7583,100 +6905,6 @@
               </a:spcAft>
               <a:defRPr sz="1700" b="1">
                 <a:solidFill>
-                  <a:srgbClr val="162B43"/>
-                </a:solidFill>
-                <a:latin typeface="DejaVu Sans"/>
-              </a:defRPr>
-            </a:pPr>
-            <a:r>
-              <a:t>Find dependencies</a:t>
-            </a:r>
-          </a:p>
-        </p:txBody>
-      </p:sp>
-      <p:sp>
-        <p:nvSpPr>
-          <p:cNvPr id="15" name="TextBox 14"/>
-          <p:cNvSpPr txBox="1"/>
-          <p:nvPr/>
-        </p:nvSpPr>
-        <p:spPr>
-          <a:xfrm>
-            <a:off x="3575304" y="3364992"/>
-            <a:ext cx="2231136" cy="566928"/>
-          </a:xfrm>
-          <a:prstGeom prst="rect">
-            <a:avLst/>
-          </a:prstGeom>
-          <a:noFill/>
-        </p:spPr>
-        <p:txBody>
-          <a:bodyPr wrap="square" lIns="0" rIns="0" tIns="0" bIns="0">
-            <a:spAutoFit/>
-          </a:bodyPr>
-          <a:lstStyle/>
-          <a:p>
-            <a:pPr>
-              <a:spcAft>
-                <a:spcPts val="700"/>
-              </a:spcAft>
-              <a:defRPr sz="1300" b="0">
-                <a:solidFill>
-                  <a:srgbClr val="25364A"/>
-                </a:solidFill>
-                <a:latin typeface="DejaVu Sans"/>
-              </a:defRPr>
-            </a:pPr>
-            <a:r>
-              <a:t>Which modules cite</a:t>
-            </a:r>
-          </a:p>
-          <a:p>
-            <a:pPr>
-              <a:spcAft>
-                <a:spcPts val="700"/>
-              </a:spcAft>
-              <a:defRPr sz="1300" b="0">
-                <a:solidFill>
-                  <a:srgbClr val="25364A"/>
-                </a:solidFill>
-                <a:latin typeface="DejaVu Sans"/>
-              </a:defRPr>
-            </a:pPr>
-            <a:r>
-              <a:t>or rely on it?</a:t>
-            </a:r>
-          </a:p>
-        </p:txBody>
-      </p:sp>
-      <p:sp>
-        <p:nvSpPr>
-          <p:cNvPr id="16" name="TextBox 15"/>
-          <p:cNvSpPr txBox="1"/>
-          <p:nvPr/>
-        </p:nvSpPr>
-        <p:spPr>
-          <a:xfrm>
-            <a:off x="6025896" y="3163824"/>
-            <a:ext cx="219456" cy="310896"/>
-          </a:xfrm>
-          <a:prstGeom prst="rect">
-            <a:avLst/>
-          </a:prstGeom>
-          <a:noFill/>
-        </p:spPr>
-        <p:txBody>
-          <a:bodyPr wrap="square" lIns="0" rIns="0" tIns="0" bIns="0">
-            <a:spAutoFit/>
-          </a:bodyPr>
-          <a:lstStyle/>
-          <a:p>
-            <a:pPr>
-              <a:spcAft>
-                <a:spcPts val="700"/>
-              </a:spcAft>
-              <a:defRPr sz="1600" b="1">
-                <a:solidFill>
                   <a:srgbClr val="147D78"/>
                 </a:solidFill>
                 <a:latin typeface="DejaVu Sans"/>
@@ -7696,8 +6924,8 @@
         </p:nvSpPr>
         <p:spPr>
           <a:xfrm>
-            <a:off x="6227064" y="2624328"/>
-            <a:ext cx="2560320" cy="1463040"/>
+            <a:off x="6227064" y="2825496"/>
+            <a:ext cx="2560320" cy="1810512"/>
           </a:xfrm>
           <a:prstGeom prst="roundRect">
             <a:avLst>
@@ -7741,8 +6969,102 @@
         </p:nvSpPr>
         <p:spPr>
           <a:xfrm>
-            <a:off x="6391656" y="2834640"/>
-            <a:ext cx="2231136" cy="320040"/>
+            <a:off x="6409944" y="3108960"/>
+            <a:ext cx="2194560" cy="658368"/>
+          </a:xfrm>
+          <a:prstGeom prst="rect">
+            <a:avLst/>
+          </a:prstGeom>
+          <a:noFill/>
+        </p:spPr>
+        <p:txBody>
+          <a:bodyPr wrap="square" lIns="0" rIns="0" tIns="0" bIns="0">
+            <a:spAutoFit/>
+          </a:bodyPr>
+          <a:lstStyle/>
+          <a:p>
+            <a:pPr>
+              <a:spcAft>
+                <a:spcPts val="700"/>
+              </a:spcAft>
+              <a:defRPr sz="1800" b="1">
+                <a:solidFill>
+                  <a:srgbClr val="162B43"/>
+                </a:solidFill>
+                <a:latin typeface="DejaVu Sans"/>
+              </a:defRPr>
+            </a:pPr>
+            <a:r>
+              <a:t>3. Lawyer reviews</a:t>
+            </a:r>
+          </a:p>
+        </p:txBody>
+      </p:sp>
+      <p:sp>
+        <p:nvSpPr>
+          <p:cNvPr id="19" name="TextBox 18"/>
+          <p:cNvSpPr txBox="1"/>
+          <p:nvPr/>
+        </p:nvSpPr>
+        <p:spPr>
+          <a:xfrm>
+            <a:off x="6409944" y="3904487"/>
+            <a:ext cx="2194560" cy="594360"/>
+          </a:xfrm>
+          <a:prstGeom prst="rect">
+            <a:avLst/>
+          </a:prstGeom>
+          <a:noFill/>
+        </p:spPr>
+        <p:txBody>
+          <a:bodyPr wrap="square" lIns="0" rIns="0" tIns="0" bIns="0">
+            <a:spAutoFit/>
+          </a:bodyPr>
+          <a:lstStyle/>
+          <a:p>
+            <a:pPr>
+              <a:spcAft>
+                <a:spcPts val="700"/>
+              </a:spcAft>
+              <a:defRPr sz="1500" b="0">
+                <a:solidFill>
+                  <a:srgbClr val="25364A"/>
+                </a:solidFill>
+                <a:latin typeface="DejaVu Sans"/>
+              </a:defRPr>
+            </a:pPr>
+            <a:r>
+              <a:t>Confirm whether</a:t>
+            </a:r>
+          </a:p>
+          <a:p>
+            <a:pPr>
+              <a:spcAft>
+                <a:spcPts val="700"/>
+              </a:spcAft>
+              <a:defRPr sz="1500" b="0">
+                <a:solidFill>
+                  <a:srgbClr val="25364A"/>
+                </a:solidFill>
+                <a:latin typeface="DejaVu Sans"/>
+              </a:defRPr>
+            </a:pPr>
+            <a:r>
+              <a:t>a rule should change.</a:t>
+            </a:r>
+          </a:p>
+        </p:txBody>
+      </p:sp>
+      <p:sp>
+        <p:nvSpPr>
+          <p:cNvPr id="20" name="TextBox 19"/>
+          <p:cNvSpPr txBox="1"/>
+          <p:nvPr/>
+        </p:nvSpPr>
+        <p:spPr>
+          <a:xfrm>
+            <a:off x="8842248" y="3602736"/>
+            <a:ext cx="219456" cy="310896"/>
           </a:xfrm>
           <a:prstGeom prst="rect">
             <a:avLst/>
@@ -7761,100 +7083,6 @@
               </a:spcAft>
               <a:defRPr sz="1700" b="1">
                 <a:solidFill>
-                  <a:srgbClr val="162B43"/>
-                </a:solidFill>
-                <a:latin typeface="DejaVu Sans"/>
-              </a:defRPr>
-            </a:pPr>
-            <a:r>
-              <a:t>Run regression</a:t>
-            </a:r>
-          </a:p>
-        </p:txBody>
-      </p:sp>
-      <p:sp>
-        <p:nvSpPr>
-          <p:cNvPr id="19" name="TextBox 18"/>
-          <p:cNvSpPr txBox="1"/>
-          <p:nvPr/>
-        </p:nvSpPr>
-        <p:spPr>
-          <a:xfrm>
-            <a:off x="6391656" y="3364992"/>
-            <a:ext cx="2231136" cy="566928"/>
-          </a:xfrm>
-          <a:prstGeom prst="rect">
-            <a:avLst/>
-          </a:prstGeom>
-          <a:noFill/>
-        </p:spPr>
-        <p:txBody>
-          <a:bodyPr wrap="square" lIns="0" rIns="0" tIns="0" bIns="0">
-            <a:spAutoFit/>
-          </a:bodyPr>
-          <a:lstStyle/>
-          <a:p>
-            <a:pPr>
-              <a:spcAft>
-                <a:spcPts val="700"/>
-              </a:spcAft>
-              <a:defRPr sz="1300" b="0">
-                <a:solidFill>
-                  <a:srgbClr val="25364A"/>
-                </a:solidFill>
-                <a:latin typeface="DejaVu Sans"/>
-              </a:defRPr>
-            </a:pPr>
-            <a:r>
-              <a:t>Compare against</a:t>
-            </a:r>
-          </a:p>
-          <a:p>
-            <a:pPr>
-              <a:spcAft>
-                <a:spcPts val="700"/>
-              </a:spcAft>
-              <a:defRPr sz="1300" b="0">
-                <a:solidFill>
-                  <a:srgbClr val="25364A"/>
-                </a:solidFill>
-                <a:latin typeface="DejaVu Sans"/>
-              </a:defRPr>
-            </a:pPr>
-            <a:r>
-              <a:t>approved examples</a:t>
-            </a:r>
-          </a:p>
-        </p:txBody>
-      </p:sp>
-      <p:sp>
-        <p:nvSpPr>
-          <p:cNvPr id="20" name="TextBox 19"/>
-          <p:cNvSpPr txBox="1"/>
-          <p:nvPr/>
-        </p:nvSpPr>
-        <p:spPr>
-          <a:xfrm>
-            <a:off x="8842248" y="3163824"/>
-            <a:ext cx="219456" cy="310896"/>
-          </a:xfrm>
-          <a:prstGeom prst="rect">
-            <a:avLst/>
-          </a:prstGeom>
-          <a:noFill/>
-        </p:spPr>
-        <p:txBody>
-          <a:bodyPr wrap="square" lIns="0" rIns="0" tIns="0" bIns="0">
-            <a:spAutoFit/>
-          </a:bodyPr>
-          <a:lstStyle/>
-          <a:p>
-            <a:pPr>
-              <a:spcAft>
-                <a:spcPts val="700"/>
-              </a:spcAft>
-              <a:defRPr sz="1600" b="1">
-                <a:solidFill>
                   <a:srgbClr val="147D78"/>
                 </a:solidFill>
                 <a:latin typeface="DejaVu Sans"/>
@@ -7874,8 +7102,8 @@
         </p:nvSpPr>
         <p:spPr>
           <a:xfrm>
-            <a:off x="9043416" y="2624328"/>
-            <a:ext cx="2560320" cy="1463040"/>
+            <a:off x="9043416" y="2825496"/>
+            <a:ext cx="2560320" cy="1810512"/>
           </a:xfrm>
           <a:prstGeom prst="roundRect">
             <a:avLst>
@@ -7919,8 +7147,8 @@
         </p:nvSpPr>
         <p:spPr>
           <a:xfrm>
-            <a:off x="9208008" y="2834640"/>
-            <a:ext cx="2231136" cy="320040"/>
+            <a:off x="9226296" y="3108960"/>
+            <a:ext cx="2194560" cy="658368"/>
           </a:xfrm>
           <a:prstGeom prst="rect">
             <a:avLst/>
@@ -7937,7 +7165,7 @@
               <a:spcAft>
                 <a:spcPts val="700"/>
               </a:spcAft>
-              <a:defRPr sz="1700" b="1">
+              <a:defRPr sz="1800" b="1">
                 <a:solidFill>
                   <a:srgbClr val="162B43"/>
                 </a:solidFill>
@@ -7945,7 +7173,7 @@
               </a:defRPr>
             </a:pPr>
             <a:r>
-              <a:t>Review differences</a:t>
+              <a:t>4. Check the change</a:t>
             </a:r>
           </a:p>
         </p:txBody>
@@ -7958,102 +7186,8 @@
         </p:nvSpPr>
         <p:spPr>
           <a:xfrm>
-            <a:off x="9208008" y="3364992"/>
-            <a:ext cx="2231136" cy="566928"/>
-          </a:xfrm>
-          <a:prstGeom prst="rect">
-            <a:avLst/>
-          </a:prstGeom>
-          <a:noFill/>
-        </p:spPr>
-        <p:txBody>
-          <a:bodyPr wrap="square" lIns="0" rIns="0" tIns="0" bIns="0">
-            <a:spAutoFit/>
-          </a:bodyPr>
-          <a:lstStyle/>
-          <a:p>
-            <a:pPr>
-              <a:spcAft>
-                <a:spcPts val="700"/>
-              </a:spcAft>
-              <a:defRPr sz="1300" b="0">
-                <a:solidFill>
-                  <a:srgbClr val="25364A"/>
-                </a:solidFill>
-                <a:latin typeface="DejaVu Sans"/>
-              </a:defRPr>
-            </a:pPr>
-            <a:r>
-              <a:t>Lawyer confirms</a:t>
-            </a:r>
-          </a:p>
-          <a:p>
-            <a:pPr>
-              <a:spcAft>
-                <a:spcPts val="700"/>
-              </a:spcAft>
-              <a:defRPr sz="1300" b="0">
-                <a:solidFill>
-                  <a:srgbClr val="25364A"/>
-                </a:solidFill>
-                <a:latin typeface="DejaVu Sans"/>
-              </a:defRPr>
-            </a:pPr>
-            <a:r>
-              <a:t>what should change</a:t>
-            </a:r>
-          </a:p>
-        </p:txBody>
-      </p:sp>
-      <p:sp>
-        <p:nvSpPr>
-          <p:cNvPr id="24" name="TextBox 23"/>
-          <p:cNvSpPr txBox="1"/>
-          <p:nvPr/>
-        </p:nvSpPr>
-        <p:spPr>
-          <a:xfrm>
-            <a:off x="594360" y="4489704"/>
-            <a:ext cx="5212080" cy="320040"/>
-          </a:xfrm>
-          <a:prstGeom prst="rect">
-            <a:avLst/>
-          </a:prstGeom>
-          <a:noFill/>
-        </p:spPr>
-        <p:txBody>
-          <a:bodyPr wrap="square" lIns="0" rIns="0" tIns="0" bIns="0">
-            <a:spAutoFit/>
-          </a:bodyPr>
-          <a:lstStyle/>
-          <a:p>
-            <a:pPr>
-              <a:spcAft>
-                <a:spcPts val="700"/>
-              </a:spcAft>
-              <a:defRPr sz="1900" b="1">
-                <a:solidFill>
-                  <a:srgbClr val="162B43"/>
-                </a:solidFill>
-                <a:latin typeface="DejaVu Sans"/>
-              </a:defRPr>
-            </a:pPr>
-            <a:r>
-              <a:t>What the checks protect</a:t>
-            </a:r>
-          </a:p>
-        </p:txBody>
-      </p:sp>
-      <p:sp>
-        <p:nvSpPr>
-          <p:cNvPr id="25" name="TextBox 24"/>
-          <p:cNvSpPr txBox="1"/>
-          <p:nvPr/>
-        </p:nvSpPr>
-        <p:spPr>
-          <a:xfrm>
-            <a:off x="594360" y="4983480"/>
-            <a:ext cx="5303520" cy="950976"/>
+            <a:off x="9226296" y="3904487"/>
+            <a:ext cx="2194560" cy="594360"/>
           </a:xfrm>
           <a:prstGeom prst="rect">
             <a:avLst/>
@@ -8078,7 +7212,7 @@
               </a:defRPr>
             </a:pPr>
             <a:r>
-              <a:t>Reproducibility</a:t>
+              <a:t>Compare agreed cases;</a:t>
             </a:r>
           </a:p>
           <a:p>
@@ -8094,37 +7228,21 @@
               </a:defRPr>
             </a:pPr>
             <a:r>
-              <a:t>Expected module order and citations</a:t>
-            </a:r>
-          </a:p>
-          <a:p>
-            <a:pPr>
-              <a:spcAft>
-                <a:spcPts val="700"/>
-              </a:spcAft>
-              <a:defRPr sz="1500" b="0">
-                <a:solidFill>
-                  <a:srgbClr val="25364A"/>
-                </a:solidFill>
-                <a:latin typeface="DejaVu Sans"/>
-              </a:defRPr>
-            </a:pPr>
-            <a:r>
-              <a:t>Dependencies, exclusions and update alerts</a:t>
-            </a:r>
-          </a:p>
-        </p:txBody>
-      </p:sp>
-      <p:sp>
-        <p:nvSpPr>
-          <p:cNvPr id="26" name="Rounded Rectangle 25"/>
+              <a:t>review differences.</a:t>
+            </a:r>
+          </a:p>
+        </p:txBody>
+      </p:sp>
+      <p:sp>
+        <p:nvSpPr>
+          <p:cNvPr id="24" name="Rounded Rectangle 23"/>
           <p:cNvSpPr/>
           <p:nvPr/>
         </p:nvSpPr>
         <p:spPr>
           <a:xfrm>
-            <a:off x="6419088" y="4453128"/>
-            <a:ext cx="5175504" cy="1600200"/>
+            <a:off x="594360" y="5239512"/>
+            <a:ext cx="11000232" cy="749808"/>
           </a:xfrm>
           <a:prstGeom prst="roundRect">
             <a:avLst>
@@ -8162,14 +7280,14 @@
       </p:sp>
       <p:sp>
         <p:nvSpPr>
-          <p:cNvPr id="27" name="TextBox 26"/>
+          <p:cNvPr id="25" name="TextBox 24"/>
           <p:cNvSpPr txBox="1"/>
           <p:nvPr/>
         </p:nvSpPr>
         <p:spPr>
           <a:xfrm>
-            <a:off x="6629400" y="4645152"/>
-            <a:ext cx="4718304" cy="274320"/>
+            <a:off x="859536" y="5468112"/>
+            <a:ext cx="10497312" cy="365760"/>
           </a:xfrm>
           <a:prstGeom prst="rect">
             <a:avLst/>
@@ -8186,70 +7304,15 @@
               <a:spcAft>
                 <a:spcPts val="700"/>
               </a:spcAft>
-              <a:defRPr sz="1100" b="1">
-                <a:solidFill>
-                  <a:srgbClr val="147D78"/>
+              <a:defRPr sz="1800" b="1">
+                <a:solidFill>
+                  <a:srgbClr val="162B43"/>
                 </a:solidFill>
                 <a:latin typeface="DejaVu Sans"/>
               </a:defRPr>
             </a:pPr>
             <a:r>
-              <a:t>APPEALS EXTENSION</a:t>
-            </a:r>
-          </a:p>
-        </p:txBody>
-      </p:sp>
-      <p:sp>
-        <p:nvSpPr>
-          <p:cNvPr id="28" name="TextBox 27"/>
-          <p:cNvSpPr txBox="1"/>
-          <p:nvPr/>
-        </p:nvSpPr>
-        <p:spPr>
-          <a:xfrm>
-            <a:off x="6629400" y="5093208"/>
-            <a:ext cx="4718304" cy="777240"/>
-          </a:xfrm>
-          <a:prstGeom prst="rect">
-            <a:avLst/>
-          </a:prstGeom>
-          <a:noFill/>
-        </p:spPr>
-        <p:txBody>
-          <a:bodyPr wrap="square" lIns="0" rIns="0" tIns="0" bIns="0">
-            <a:spAutoFit/>
-          </a:bodyPr>
-          <a:lstStyle/>
-          <a:p>
-            <a:pPr>
-              <a:spcAft>
-                <a:spcPts val="700"/>
-              </a:spcAft>
-              <a:defRPr sz="1500" b="0">
-                <a:solidFill>
-                  <a:srgbClr val="162B43"/>
-                </a:solidFill>
-                <a:latin typeface="DejaVu Sans"/>
-              </a:defRPr>
-            </a:pPr>
-            <a:r>
-              <a:t>Map findings, reasoning and authorities</a:t>
-            </a:r>
-          </a:p>
-          <a:p>
-            <a:pPr>
-              <a:spcAft>
-                <a:spcPts val="700"/>
-              </a:spcAft>
-              <a:defRPr sz="1500" b="0">
-                <a:solidFill>
-                  <a:srgbClr val="162B43"/>
-                </a:solidFill>
-                <a:latin typeface="DejaVu Sans"/>
-              </a:defRPr>
-            </a:pPr>
-            <a:r>
-              <a:t>for a lawyer to assess potential appeal grounds.</a:t>
+              <a:t>The review record shows what changed, why, and which cases were checked.</a:t>
             </a:r>
           </a:p>
         </p:txBody>
@@ -8357,7 +7420,7 @@
               </a:defRPr>
             </a:pPr>
             <a:r>
-              <a:t>EVIDENCE · FIRST CONTRIBUTION</a:t>
+              <a:t>MY CONTRIBUTION · A PRACTICAL STARTING POINT</a:t>
             </a:r>
           </a:p>
         </p:txBody>
@@ -8396,7 +7459,7 @@
               </a:defRPr>
             </a:pPr>
             <a:r>
-              <a:t>Small, explainable work before broader automation</a:t>
+              <a:t>One workflow. A small pilot. Evidence to review.</a:t>
             </a:r>
           </a:p>
         </p:txBody>
@@ -8435,7 +7498,7 @@
               </a:defRPr>
             </a:pPr>
             <a:r>
-              <a:t>My earlier research contribution and recent demonstrations are distinct.</a:t>
+              <a:t>Learn the process first; agree on examples and a useful measure with the team.</a:t>
             </a:r>
           </a:p>
         </p:txBody>
@@ -8517,7 +7580,7 @@
               </a:defRPr>
             </a:pPr>
             <a:r>
-              <a:t>Evidence: github.com/nafismam/UkilRAG and github.com/nafismam/LearnRAG. No production or legal-accuracy claim.</a:t>
+              <a:t>Project demonstrations use synthetic legal examples. Earlier research contribution is separate from the recent implementations.</a:t>
             </a:r>
           </a:p>
         </p:txBody>
@@ -8569,8 +7632,8 @@
         </p:nvSpPr>
         <p:spPr>
           <a:xfrm>
-            <a:off x="594360" y="2624328"/>
-            <a:ext cx="5486400" cy="3246120"/>
+            <a:off x="594360" y="2724912"/>
+            <a:ext cx="5486400" cy="2953512"/>
           </a:xfrm>
           <a:prstGeom prst="roundRect">
             <a:avLst>
@@ -8614,8 +7677,8 @@
         </p:nvSpPr>
         <p:spPr>
           <a:xfrm>
-            <a:off x="804672" y="2816352"/>
-            <a:ext cx="5065776" cy="274320"/>
+            <a:off x="841248" y="2980944"/>
+            <a:ext cx="4992624" cy="274320"/>
           </a:xfrm>
           <a:prstGeom prst="rect">
             <a:avLst/>
@@ -8640,7 +7703,7 @@
               </a:defRPr>
             </a:pPr>
             <a:r>
-              <a:t>WHAT I CAN DISCUSS</a:t>
+              <a:t>RELEVANT BACKGROUND</a:t>
             </a:r>
           </a:p>
         </p:txBody>
@@ -8653,8 +7716,8 @@
         </p:nvSpPr>
         <p:spPr>
           <a:xfrm>
-            <a:off x="804672" y="3264408"/>
-            <a:ext cx="5047488" cy="658368"/>
+            <a:off x="841248" y="3456432"/>
+            <a:ext cx="4937760" cy="777240"/>
           </a:xfrm>
           <a:prstGeom prst="rect">
             <a:avLst/>
@@ -8671,7 +7734,7 @@
               <a:spcAft>
                 <a:spcPts val="700"/>
               </a:spcAft>
-              <a:defRPr sz="1600" b="1">
+              <a:defRPr sz="1700" b="1">
                 <a:solidFill>
                   <a:srgbClr val="162B43"/>
                 </a:solidFill>
@@ -8679,7 +7742,7 @@
               </a:defRPr>
             </a:pPr>
             <a:r>
-              <a:t>Earlier research: literature review, problem</a:t>
+              <a:t>Earlier research: literature review,</a:t>
             </a:r>
           </a:p>
           <a:p>
@@ -8687,7 +7750,7 @@
               <a:spcAft>
                 <a:spcPts val="700"/>
               </a:spcAft>
-              <a:defRPr sz="1600" b="1">
+              <a:defRPr sz="1700" b="1">
                 <a:solidFill>
                   <a:srgbClr val="162B43"/>
                 </a:solidFill>
@@ -8695,7 +7758,7 @@
               </a:defRPr>
             </a:pPr>
             <a:r>
-              <a:t>identification and initial design.</a:t>
+              <a:t>problem identification and initial design.</a:t>
             </a:r>
           </a:p>
         </p:txBody>
@@ -8708,8 +7771,257 @@
         </p:nvSpPr>
         <p:spPr>
           <a:xfrm>
-            <a:off x="804672" y="4123944"/>
-            <a:ext cx="5029200" cy="676656"/>
+            <a:off x="841248" y="4517136"/>
+            <a:ext cx="4937760" cy="594360"/>
+          </a:xfrm>
+          <a:prstGeom prst="rect">
+            <a:avLst/>
+          </a:prstGeom>
+          <a:noFill/>
+        </p:spPr>
+        <p:txBody>
+          <a:bodyPr wrap="square" lIns="0" rIns="0" tIns="0" bIns="0">
+            <a:spAutoFit/>
+          </a:bodyPr>
+          <a:lstStyle/>
+          <a:p>
+            <a:pPr>
+              <a:spcAft>
+                <a:spcPts val="700"/>
+              </a:spcAft>
+              <a:defRPr sz="1600" b="0">
+                <a:solidFill>
+                  <a:srgbClr val="25364A"/>
+                </a:solidFill>
+                <a:latin typeface="DejaVu Sans"/>
+              </a:defRPr>
+            </a:pPr>
+            <a:r>
+              <a:t>Recent demos: explainable drafting checks</a:t>
+            </a:r>
+          </a:p>
+          <a:p>
+            <a:pPr>
+              <a:spcAft>
+                <a:spcPts val="700"/>
+              </a:spcAft>
+              <a:defRPr sz="1600" b="0">
+                <a:solidFill>
+                  <a:srgbClr val="25364A"/>
+                </a:solidFill>
+                <a:latin typeface="DejaVu Sans"/>
+              </a:defRPr>
+            </a:pPr>
+            <a:r>
+              <a:t>and source-backed retrieval.</a:t>
+            </a:r>
+          </a:p>
+        </p:txBody>
+      </p:sp>
+      <p:sp>
+        <p:nvSpPr>
+          <p:cNvPr id="13" name="TextBox 12"/>
+          <p:cNvSpPr txBox="1"/>
+          <p:nvPr/>
+        </p:nvSpPr>
+        <p:spPr>
+          <a:xfrm>
+            <a:off x="841248" y="5202936"/>
+            <a:ext cx="2286000" cy="274320"/>
+          </a:xfrm>
+          <a:prstGeom prst="rect">
+            <a:avLst/>
+          </a:prstGeom>
+          <a:noFill/>
+        </p:spPr>
+        <p:txBody>
+          <a:bodyPr wrap="square" lIns="0" rIns="0" tIns="0" bIns="0">
+            <a:spAutoFit/>
+          </a:bodyPr>
+          <a:lstStyle/>
+          <a:p>
+            <a:pPr>
+              <a:spcAft>
+                <a:spcPts val="700"/>
+              </a:spcAft>
+              <a:defRPr sz="1200" b="1">
+                <a:solidFill>
+                  <a:srgbClr val="147D78"/>
+                </a:solidFill>
+                <a:latin typeface="DejaVu Sans"/>
+              </a:defRPr>
+            </a:pPr>
+            <a:r>
+              <a:rPr>
+                <a:hlinkClick r:id="rId2"/>
+              </a:rPr>
+              <a:t>UkilRAG ↗</a:t>
+            </a:r>
+          </a:p>
+        </p:txBody>
+      </p:sp>
+      <p:sp>
+        <p:nvSpPr>
+          <p:cNvPr id="14" name="TextBox 13"/>
+          <p:cNvSpPr txBox="1"/>
+          <p:nvPr/>
+        </p:nvSpPr>
+        <p:spPr>
+          <a:xfrm>
+            <a:off x="3346704" y="5202936"/>
+            <a:ext cx="2286000" cy="274320"/>
+          </a:xfrm>
+          <a:prstGeom prst="rect">
+            <a:avLst/>
+          </a:prstGeom>
+          <a:noFill/>
+        </p:spPr>
+        <p:txBody>
+          <a:bodyPr wrap="square" lIns="0" rIns="0" tIns="0" bIns="0">
+            <a:spAutoFit/>
+          </a:bodyPr>
+          <a:lstStyle/>
+          <a:p>
+            <a:pPr>
+              <a:spcAft>
+                <a:spcPts val="700"/>
+              </a:spcAft>
+              <a:defRPr sz="1200" b="1">
+                <a:solidFill>
+                  <a:srgbClr val="147D78"/>
+                </a:solidFill>
+                <a:latin typeface="DejaVu Sans"/>
+              </a:defRPr>
+            </a:pPr>
+            <a:r>
+              <a:rPr>
+                <a:hlinkClick r:id="rId3"/>
+              </a:rPr>
+              <a:t>LearnRAG ↗</a:t>
+            </a:r>
+          </a:p>
+        </p:txBody>
+      </p:sp>
+      <p:sp>
+        <p:nvSpPr>
+          <p:cNvPr id="15" name="TextBox 14"/>
+          <p:cNvSpPr txBox="1"/>
+          <p:nvPr/>
+        </p:nvSpPr>
+        <p:spPr>
+          <a:xfrm>
+            <a:off x="6565392" y="2962656"/>
+            <a:ext cx="4846320" cy="274320"/>
+          </a:xfrm>
+          <a:prstGeom prst="rect">
+            <a:avLst/>
+          </a:prstGeom>
+          <a:noFill/>
+        </p:spPr>
+        <p:txBody>
+          <a:bodyPr wrap="square" lIns="0" rIns="0" tIns="0" bIns="0">
+            <a:spAutoFit/>
+          </a:bodyPr>
+          <a:lstStyle/>
+          <a:p>
+            <a:pPr>
+              <a:spcAft>
+                <a:spcPts val="700"/>
+              </a:spcAft>
+              <a:defRPr sz="1100" b="1">
+                <a:solidFill>
+                  <a:srgbClr val="147D78"/>
+                </a:solidFill>
+                <a:latin typeface="DejaVu Sans"/>
+              </a:defRPr>
+            </a:pPr>
+            <a:r>
+              <a:t>PROPOSED FIRST CONTRIBUTION</a:t>
+            </a:r>
+          </a:p>
+        </p:txBody>
+      </p:sp>
+      <p:sp>
+        <p:nvSpPr>
+          <p:cNvPr id="16" name="TextBox 15"/>
+          <p:cNvSpPr txBox="1"/>
+          <p:nvPr/>
+        </p:nvSpPr>
+        <p:spPr>
+          <a:xfrm>
+            <a:off x="6565392" y="3483864"/>
+            <a:ext cx="4846320" cy="1737360"/>
+          </a:xfrm>
+          <a:prstGeom prst="rect">
+            <a:avLst/>
+          </a:prstGeom>
+          <a:noFill/>
+        </p:spPr>
+        <p:txBody>
+          <a:bodyPr wrap="square" lIns="0" rIns="0" tIns="0" bIns="0">
+            <a:spAutoFit/>
+          </a:bodyPr>
+          <a:lstStyle/>
+          <a:p>
+            <a:pPr>
+              <a:spcAft>
+                <a:spcPts val="700"/>
+              </a:spcAft>
+              <a:defRPr sz="2000" b="1">
+                <a:solidFill>
+                  <a:srgbClr val="162B43"/>
+                </a:solidFill>
+                <a:latin typeface="DejaVu Sans"/>
+              </a:defRPr>
+            </a:pPr>
+            <a:r>
+              <a:t>Map one workflow with a lawyer.</a:t>
+            </a:r>
+          </a:p>
+          <a:p>
+            <a:pPr>
+              <a:spcAft>
+                <a:spcPts val="700"/>
+              </a:spcAft>
+              <a:defRPr sz="2000" b="1">
+                <a:solidFill>
+                  <a:srgbClr val="162B43"/>
+                </a:solidFill>
+                <a:latin typeface="DejaVu Sans"/>
+              </a:defRPr>
+            </a:pPr>
+            <a:r>
+              <a:t>Build and check one small pilot.</a:t>
+            </a:r>
+          </a:p>
+          <a:p>
+            <a:pPr>
+              <a:spcAft>
+                <a:spcPts val="700"/>
+              </a:spcAft>
+              <a:defRPr sz="2000" b="1">
+                <a:solidFill>
+                  <a:srgbClr val="162B43"/>
+                </a:solidFill>
+                <a:latin typeface="DejaVu Sans"/>
+              </a:defRPr>
+            </a:pPr>
+            <a:r>
+              <a:t>Review results before expanding.</a:t>
+            </a:r>
+          </a:p>
+        </p:txBody>
+      </p:sp>
+      <p:sp>
+        <p:nvSpPr>
+          <p:cNvPr id="17" name="TextBox 16"/>
+          <p:cNvSpPr txBox="1"/>
+          <p:nvPr/>
+        </p:nvSpPr>
+        <p:spPr>
+          <a:xfrm>
+            <a:off x="6565392" y="5148072"/>
+            <a:ext cx="4846320" cy="640080"/>
           </a:xfrm>
           <a:prstGeom prst="rect">
             <a:avLst/>
@@ -8728,13 +8040,13 @@
               </a:spcAft>
               <a:defRPr sz="1400" b="0">
                 <a:solidFill>
-                  <a:srgbClr val="25364A"/>
+                  <a:srgbClr val="607185"/>
                 </a:solidFill>
                 <a:latin typeface="DejaVu Sans"/>
               </a:defRPr>
             </a:pPr>
             <a:r>
-              <a:t>UkilRAG: rules, traces and synthetic regressions.</a:t>
+              <a:t>Measure review effort, rework and</a:t>
             </a:r>
           </a:p>
           <a:p>
@@ -8744,278 +8056,13 @@
               </a:spcAft>
               <a:defRPr sz="1400" b="0">
                 <a:solidFill>
-                  <a:srgbClr val="25364A"/>
+                  <a:srgbClr val="607185"/>
                 </a:solidFill>
                 <a:latin typeface="DejaVu Sans"/>
               </a:defRPr>
             </a:pPr>
             <a:r>
-              <a:t>LearnRAG: real model outputs and limitations.</a:t>
-            </a:r>
-          </a:p>
-        </p:txBody>
-      </p:sp>
-      <p:sp>
-        <p:nvSpPr>
-          <p:cNvPr id="13" name="TextBox 12"/>
-          <p:cNvSpPr txBox="1"/>
-          <p:nvPr/>
-        </p:nvSpPr>
-        <p:spPr>
-          <a:xfrm>
-            <a:off x="804672" y="5166360"/>
-            <a:ext cx="2468880" cy="274320"/>
-          </a:xfrm>
-          <a:prstGeom prst="rect">
-            <a:avLst/>
-          </a:prstGeom>
-          <a:noFill/>
-        </p:spPr>
-        <p:txBody>
-          <a:bodyPr wrap="square" lIns="0" rIns="0" tIns="0" bIns="0">
-            <a:spAutoFit/>
-          </a:bodyPr>
-          <a:lstStyle/>
-          <a:p>
-            <a:pPr>
-              <a:spcAft>
-                <a:spcPts val="700"/>
-              </a:spcAft>
-              <a:defRPr sz="1200" b="1">
-                <a:solidFill>
-                  <a:srgbClr val="147D78"/>
-                </a:solidFill>
-                <a:latin typeface="DejaVu Sans"/>
-              </a:defRPr>
-            </a:pPr>
-            <a:r>
-              <a:rPr>
-                <a:hlinkClick r:id="rId2"/>
-              </a:rPr>
-              <a:t>View UkilRAG ↗</a:t>
-            </a:r>
-          </a:p>
-        </p:txBody>
-      </p:sp>
-      <p:sp>
-        <p:nvSpPr>
-          <p:cNvPr id="14" name="TextBox 13"/>
-          <p:cNvSpPr txBox="1"/>
-          <p:nvPr/>
-        </p:nvSpPr>
-        <p:spPr>
-          <a:xfrm>
-            <a:off x="3337560" y="5166360"/>
-            <a:ext cx="2468880" cy="274320"/>
-          </a:xfrm>
-          <a:prstGeom prst="rect">
-            <a:avLst/>
-          </a:prstGeom>
-          <a:noFill/>
-        </p:spPr>
-        <p:txBody>
-          <a:bodyPr wrap="square" lIns="0" rIns="0" tIns="0" bIns="0">
-            <a:spAutoFit/>
-          </a:bodyPr>
-          <a:lstStyle/>
-          <a:p>
-            <a:pPr>
-              <a:spcAft>
-                <a:spcPts val="700"/>
-              </a:spcAft>
-              <a:defRPr sz="1200" b="1">
-                <a:solidFill>
-                  <a:srgbClr val="147D78"/>
-                </a:solidFill>
-                <a:latin typeface="DejaVu Sans"/>
-              </a:defRPr>
-            </a:pPr>
-            <a:r>
-              <a:rPr>
-                <a:hlinkClick r:id="rId3"/>
-              </a:rPr>
-              <a:t>View LearnRAG ↗</a:t>
-            </a:r>
-          </a:p>
-        </p:txBody>
-      </p:sp>
-      <p:sp>
-        <p:nvSpPr>
-          <p:cNvPr id="15" name="TextBox 14"/>
-          <p:cNvSpPr txBox="1"/>
-          <p:nvPr/>
-        </p:nvSpPr>
-        <p:spPr>
-          <a:xfrm>
-            <a:off x="6537960" y="2724912"/>
-            <a:ext cx="5029200" cy="274320"/>
-          </a:xfrm>
-          <a:prstGeom prst="rect">
-            <a:avLst/>
-          </a:prstGeom>
-          <a:noFill/>
-        </p:spPr>
-        <p:txBody>
-          <a:bodyPr wrap="square" lIns="0" rIns="0" tIns="0" bIns="0">
-            <a:spAutoFit/>
-          </a:bodyPr>
-          <a:lstStyle/>
-          <a:p>
-            <a:pPr>
-              <a:spcAft>
-                <a:spcPts val="700"/>
-              </a:spcAft>
-              <a:defRPr sz="1100" b="1">
-                <a:solidFill>
-                  <a:srgbClr val="147D78"/>
-                </a:solidFill>
-                <a:latin typeface="DejaVu Sans"/>
-              </a:defRPr>
-            </a:pPr>
-            <a:r>
-              <a:t>PROPOSED FIRST MONTH</a:t>
-            </a:r>
-          </a:p>
-        </p:txBody>
-      </p:sp>
-      <p:sp>
-        <p:nvSpPr>
-          <p:cNvPr id="16" name="TextBox 15"/>
-          <p:cNvSpPr txBox="1"/>
-          <p:nvPr/>
-        </p:nvSpPr>
-        <p:spPr>
-          <a:xfrm>
-            <a:off x="6537960" y="3227832"/>
-            <a:ext cx="4892040" cy="1828800"/>
-          </a:xfrm>
-          <a:prstGeom prst="rect">
-            <a:avLst/>
-          </a:prstGeom>
-          <a:noFill/>
-        </p:spPr>
-        <p:txBody>
-          <a:bodyPr wrap="square" lIns="0" rIns="0" tIns="0" bIns="0">
-            <a:spAutoFit/>
-          </a:bodyPr>
-          <a:lstStyle/>
-          <a:p>
-            <a:pPr>
-              <a:spcAft>
-                <a:spcPts val="700"/>
-              </a:spcAft>
-              <a:defRPr sz="1600" b="0">
-                <a:solidFill>
-                  <a:srgbClr val="162B43"/>
-                </a:solidFill>
-                <a:latin typeface="DejaVu Sans"/>
-              </a:defRPr>
-            </a:pPr>
-            <a:r>
-              <a:t>Understand one workflow with the team.</a:t>
-            </a:r>
-          </a:p>
-          <a:p>
-            <a:pPr>
-              <a:spcAft>
-                <a:spcPts val="700"/>
-              </a:spcAft>
-              <a:defRPr sz="1600" b="0">
-                <a:solidFill>
-                  <a:srgbClr val="162B43"/>
-                </a:solidFill>
-                <a:latin typeface="DejaVu Sans"/>
-              </a:defRPr>
-            </a:pPr>
-            <a:r>
-              <a:t>Agree on examples and expected behavior.</a:t>
-            </a:r>
-          </a:p>
-          <a:p>
-            <a:pPr>
-              <a:spcAft>
-                <a:spcPts val="700"/>
-              </a:spcAft>
-              <a:defRPr sz="1600" b="0">
-                <a:solidFill>
-                  <a:srgbClr val="162B43"/>
-                </a:solidFill>
-                <a:latin typeface="DejaVu Sans"/>
-              </a:defRPr>
-            </a:pPr>
-            <a:r>
-              <a:t>Model and implement one bounded rule set.</a:t>
-            </a:r>
-          </a:p>
-          <a:p>
-            <a:pPr>
-              <a:spcAft>
-                <a:spcPts val="700"/>
-              </a:spcAft>
-              <a:defRPr sz="1600" b="0">
-                <a:solidFill>
-                  <a:srgbClr val="162B43"/>
-                </a:solidFill>
-                <a:latin typeface="DejaVu Sans"/>
-              </a:defRPr>
-            </a:pPr>
-            <a:r>
-              <a:t>Review test results and a baseline measure.</a:t>
-            </a:r>
-          </a:p>
-        </p:txBody>
-      </p:sp>
-      <p:sp>
-        <p:nvSpPr>
-          <p:cNvPr id="17" name="TextBox 16"/>
-          <p:cNvSpPr txBox="1"/>
-          <p:nvPr/>
-        </p:nvSpPr>
-        <p:spPr>
-          <a:xfrm>
-            <a:off x="6537960" y="5285232"/>
-            <a:ext cx="4892040" cy="594360"/>
-          </a:xfrm>
-          <a:prstGeom prst="rect">
-            <a:avLst/>
-          </a:prstGeom>
-          <a:noFill/>
-        </p:spPr>
-        <p:txBody>
-          <a:bodyPr wrap="square" lIns="0" rIns="0" tIns="0" bIns="0">
-            <a:spAutoFit/>
-          </a:bodyPr>
-          <a:lstStyle/>
-          <a:p>
-            <a:pPr>
-              <a:spcAft>
-                <a:spcPts val="700"/>
-              </a:spcAft>
-              <a:defRPr sz="1200" b="0">
-                <a:solidFill>
-                  <a:srgbClr val="607185"/>
-                </a:solidFill>
-                <a:latin typeface="DejaVu Sans"/>
-              </a:defRPr>
-            </a:pPr>
-            <a:r>
-              <a:t>Measure review time, rework and unexpected</a:t>
-            </a:r>
-          </a:p>
-          <a:p>
-            <a:pPr>
-              <a:spcAft>
-                <a:spcPts val="700"/>
-              </a:spcAft>
-              <a:defRPr sz="1200" b="0">
-                <a:solidFill>
-                  <a:srgbClr val="607185"/>
-                </a:solidFill>
-                <a:latin typeface="DejaVu Sans"/>
-              </a:defRPr>
-            </a:pPr>
-            <a:r>
-              <a:t>output changes before setting improvement targets.</a:t>
+              <a:t>unexpected changes—not promises.</a:t>
             </a:r>
           </a:p>
         </p:txBody>

</xml_diff>